<commit_message>
Strengthen hydrate ML presentation
</commit_message>
<xml_diff>
--- a/docs/project_blueprints/North_Slope_Gas_Hydrate_Reservoir_Characterization_Research_Overview.pptx
+++ b/docs/project_blueprints/North_Slope_Gas_Hydrate_Reservoir_Characterization_Research_Overview.pptx
@@ -3168,7 +3168,7 @@
       </p:sp>
       <p:pic>
         <p:nvPicPr>
-          <p:cNvPr id="4" name="Picture 3" descr="regional_3d_context.png"/>
+          <p:cNvPr id="4" name="Picture 3" descr="streamlit_3d_context_v2.png"/>
           <p:cNvPicPr>
             <a:picLocks noChangeAspect="1"/>
           </p:cNvPicPr>
@@ -5924,7 +5924,7 @@
                 </a:solidFill>
                 <a:latin typeface="Aptos"/>
               </a:rPr>
-              <a:t>Workflow adapted from gas-hydrate ML literature and approved-data constraints</a:t>
+              <a:t>ANN paper logic adapted into a leakage-controlled well-log workflow</a:t>
             </a:r>
           </a:p>
         </p:txBody>
@@ -5937,8 +5937,8 @@
         </p:nvSpPr>
         <p:spPr>
           <a:xfrm>
-            <a:off x="777240" y="1143000"/>
-            <a:ext cx="1417320" cy="621792"/>
+            <a:off x="685800" y="1078992"/>
+            <a:ext cx="2148840" cy="822960"/>
           </a:xfrm>
           <a:prstGeom prst="roundRect">
             <a:avLst/>
@@ -5982,8 +5982,8 @@
         </p:nvSpPr>
         <p:spPr>
           <a:xfrm>
-            <a:off x="886968" y="1234440"/>
-            <a:ext cx="1197864" cy="246888"/>
+            <a:off x="795528" y="1170432"/>
+            <a:ext cx="1929384" cy="246888"/>
           </a:xfrm>
           <a:prstGeom prst="rect">
             <a:avLst/>
@@ -6004,46 +6004,48 @@
                 </a:solidFill>
                 <a:latin typeface="Aptos"/>
               </a:rPr>
-              <a:t>raw logs</a:t>
-            </a:r>
-          </a:p>
-        </p:txBody>
-      </p:sp>
-      <p:cxnSp>
-        <p:nvCxnSpPr>
-          <p:cNvPr id="6" name="Connector 5"/>
-          <p:cNvCxnSpPr/>
-          <p:nvPr/>
-        </p:nvCxnSpPr>
-        <p:spPr>
-          <a:xfrm>
-            <a:off x="2212848" y="1453896"/>
-            <a:ext cx="256031" cy="0"/>
-          </a:xfrm>
-          <a:prstGeom prst="line">
-            <a:avLst/>
-          </a:prstGeom>
-          <a:ln w="25400">
-            <a:solidFill>
-              <a:srgbClr val="167D8D"/>
-            </a:solidFill>
-          </a:ln>
-        </p:spPr>
-        <p:style>
-          <a:lnRef idx="2">
-            <a:schemeClr val="accent1"/>
-          </a:lnRef>
-          <a:fillRef idx="0">
-            <a:schemeClr val="accent1"/>
-          </a:fillRef>
-          <a:effectRef idx="1">
-            <a:schemeClr val="accent1"/>
-          </a:effectRef>
-          <a:fontRef idx="minor">
-            <a:schemeClr val="tx1"/>
-          </a:fontRef>
-        </p:style>
-      </p:cxnSp>
+              <a:t>Chong et al. anchor</a:t>
+            </a:r>
+          </a:p>
+        </p:txBody>
+      </p:sp>
+      <p:sp>
+        <p:nvSpPr>
+          <p:cNvPr id="6" name="TextBox 5"/>
+          <p:cNvSpPr txBox="1"/>
+          <p:nvPr/>
+        </p:nvSpPr>
+        <p:spPr>
+          <a:xfrm>
+            <a:off x="795528" y="1463039"/>
+            <a:ext cx="1929384" cy="384048"/>
+          </a:xfrm>
+          <a:prstGeom prst="rect">
+            <a:avLst/>
+          </a:prstGeom>
+          <a:noFill/>
+        </p:spPr>
+        <p:txBody>
+          <a:bodyPr wrap="none" lIns="45720" rIns="45720" anchor="t">
+            <a:spAutoFit/>
+          </a:bodyPr>
+          <a:lstStyle/>
+          <a:p>
+            <a:pPr algn="l"/>
+            <a:r>
+              <a:rPr sz="890" b="0">
+                <a:solidFill>
+                  <a:srgbClr val="1F2933"/>
+                </a:solidFill>
+                <a:latin typeface="Aptos"/>
+              </a:rPr>
+              <a:t>5 permafrost wells
+&gt;10,000 depth points
+NMR-derived Sh target</a:t>
+            </a:r>
+          </a:p>
+        </p:txBody>
+      </p:sp>
       <p:sp>
         <p:nvSpPr>
           <p:cNvPr id="7" name="Rounded Rectangle 6"/>
@@ -6052,8 +6054,8 @@
         </p:nvSpPr>
         <p:spPr>
           <a:xfrm>
-            <a:off x="2542032" y="1143000"/>
-            <a:ext cx="1417320" cy="621792"/>
+            <a:off x="3154680" y="1078992"/>
+            <a:ext cx="2148840" cy="822960"/>
           </a:xfrm>
           <a:prstGeom prst="roundRect">
             <a:avLst/>
@@ -6097,8 +6099,8 @@
         </p:nvSpPr>
         <p:spPr>
           <a:xfrm>
-            <a:off x="2651760" y="1234440"/>
-            <a:ext cx="1197864" cy="246888"/>
+            <a:off x="3264408" y="1170432"/>
+            <a:ext cx="1929384" cy="246888"/>
           </a:xfrm>
           <a:prstGeom prst="rect">
             <a:avLst/>
@@ -6119,46 +6121,47 @@
                 </a:solidFill>
                 <a:latin typeface="Aptos"/>
               </a:rPr>
-              <a:t>QC</a:t>
-            </a:r>
-          </a:p>
-        </p:txBody>
-      </p:sp>
-      <p:cxnSp>
-        <p:nvCxnSpPr>
-          <p:cNvPr id="9" name="Connector 8"/>
-          <p:cNvCxnSpPr/>
-          <p:nvPr/>
-        </p:nvCxnSpPr>
-        <p:spPr>
-          <a:xfrm>
-            <a:off x="3977639" y="1453896"/>
-            <a:ext cx="256033" cy="0"/>
-          </a:xfrm>
-          <a:prstGeom prst="line">
-            <a:avLst/>
-          </a:prstGeom>
-          <a:ln w="25400">
-            <a:solidFill>
-              <a:srgbClr val="167D8D"/>
-            </a:solidFill>
-          </a:ln>
-        </p:spPr>
-        <p:style>
-          <a:lnRef idx="2">
-            <a:schemeClr val="accent1"/>
-          </a:lnRef>
-          <a:fillRef idx="0">
-            <a:schemeClr val="accent1"/>
-          </a:fillRef>
-          <a:effectRef idx="1">
-            <a:schemeClr val="accent1"/>
-          </a:effectRef>
-          <a:fontRef idx="minor">
-            <a:schemeClr val="tx1"/>
-          </a:fontRef>
-        </p:style>
-      </p:cxnSp>
+              <a:t>Input log families</a:t>
+            </a:r>
+          </a:p>
+        </p:txBody>
+      </p:sp>
+      <p:sp>
+        <p:nvSpPr>
+          <p:cNvPr id="9" name="TextBox 8"/>
+          <p:cNvSpPr txBox="1"/>
+          <p:nvPr/>
+        </p:nvSpPr>
+        <p:spPr>
+          <a:xfrm>
+            <a:off x="3264408" y="1463039"/>
+            <a:ext cx="1929384" cy="384048"/>
+          </a:xfrm>
+          <a:prstGeom prst="rect">
+            <a:avLst/>
+          </a:prstGeom>
+          <a:noFill/>
+        </p:spPr>
+        <p:txBody>
+          <a:bodyPr wrap="none" lIns="45720" rIns="45720" anchor="t">
+            <a:spAutoFit/>
+          </a:bodyPr>
+          <a:lstStyle/>
+          <a:p>
+            <a:pPr algn="l"/>
+            <a:r>
+              <a:rPr sz="890" b="0">
+                <a:solidFill>
+                  <a:srgbClr val="1F2933"/>
+                </a:solidFill>
+                <a:latin typeface="Aptos"/>
+              </a:rPr>
+              <a:t>density, porosity, Rt, GR,
+Vp and Vs candidates</a:t>
+            </a:r>
+          </a:p>
+        </p:txBody>
+      </p:sp>
       <p:sp>
         <p:nvSpPr>
           <p:cNvPr id="10" name="Rounded Rectangle 9"/>
@@ -6167,8 +6170,8 @@
         </p:nvSpPr>
         <p:spPr>
           <a:xfrm>
-            <a:off x="4306824" y="1143000"/>
-            <a:ext cx="1417320" cy="621792"/>
+            <a:off x="5623560" y="1078992"/>
+            <a:ext cx="2148840" cy="822960"/>
           </a:xfrm>
           <a:prstGeom prst="roundRect">
             <a:avLst/>
@@ -6212,7 +6215,239 @@
         </p:nvSpPr>
         <p:spPr>
           <a:xfrm>
-            <a:off x="4416552" y="1234440"/>
+            <a:off x="5733288" y="1170432"/>
+            <a:ext cx="1929384" cy="246888"/>
+          </a:xfrm>
+          <a:prstGeom prst="rect">
+            <a:avLst/>
+          </a:prstGeom>
+          <a:noFill/>
+        </p:spPr>
+        <p:txBody>
+          <a:bodyPr wrap="none" lIns="45720" rIns="45720" anchor="t">
+            <a:spAutoFit/>
+          </a:bodyPr>
+          <a:lstStyle/>
+          <a:p>
+            <a:pPr algn="l"/>
+            <a:r>
+              <a:rPr sz="1220" b="1">
+                <a:solidFill>
+                  <a:srgbClr val="123447"/>
+                </a:solidFill>
+                <a:latin typeface="Aptos"/>
+              </a:rPr>
+              <a:t>Project target control</a:t>
+            </a:r>
+          </a:p>
+        </p:txBody>
+      </p:sp>
+      <p:sp>
+        <p:nvSpPr>
+          <p:cNvPr id="12" name="TextBox 11"/>
+          <p:cNvSpPr txBox="1"/>
+          <p:nvPr/>
+        </p:nvSpPr>
+        <p:spPr>
+          <a:xfrm>
+            <a:off x="5733288" y="1463039"/>
+            <a:ext cx="1929384" cy="384048"/>
+          </a:xfrm>
+          <a:prstGeom prst="rect">
+            <a:avLst/>
+          </a:prstGeom>
+          <a:noFill/>
+        </p:spPr>
+        <p:txBody>
+          <a:bodyPr wrap="none" lIns="45720" rIns="45720" anchor="t">
+            <a:spAutoFit/>
+          </a:bodyPr>
+          <a:lstStyle/>
+          <a:p>
+            <a:pPr algn="l"/>
+            <a:r>
+              <a:rPr sz="890" b="0">
+                <a:solidFill>
+                  <a:srgbClr val="1F2933"/>
+                </a:solidFill>
+                <a:latin typeface="Aptos"/>
+              </a:rPr>
+              <a:t>NMR/core saturation is a label,
+not an input when target-derived</a:t>
+            </a:r>
+          </a:p>
+        </p:txBody>
+      </p:sp>
+      <p:sp>
+        <p:nvSpPr>
+          <p:cNvPr id="13" name="Rounded Rectangle 12"/>
+          <p:cNvSpPr/>
+          <p:nvPr/>
+        </p:nvSpPr>
+        <p:spPr>
+          <a:xfrm>
+            <a:off x="8092440" y="1078992"/>
+            <a:ext cx="2148840" cy="822960"/>
+          </a:xfrm>
+          <a:prstGeom prst="roundRect">
+            <a:avLst/>
+          </a:prstGeom>
+          <a:solidFill>
+            <a:srgbClr val="F4EFE6"/>
+          </a:solidFill>
+          <a:ln w="13970">
+            <a:solidFill>
+              <a:srgbClr val="167D8D"/>
+            </a:solidFill>
+          </a:ln>
+        </p:spPr>
+        <p:style>
+          <a:lnRef idx="1">
+            <a:schemeClr val="accent1"/>
+          </a:lnRef>
+          <a:fillRef idx="3">
+            <a:schemeClr val="accent1"/>
+          </a:fillRef>
+          <a:effectRef idx="2">
+            <a:schemeClr val="accent1"/>
+          </a:effectRef>
+          <a:fontRef idx="minor">
+            <a:schemeClr val="lt1"/>
+          </a:fontRef>
+        </p:style>
+        <p:txBody>
+          <a:bodyPr rtlCol="0" anchor="ctr"/>
+          <a:lstStyle/>
+          <a:p>
+            <a:pPr algn="ctr"/>
+          </a:p>
+        </p:txBody>
+      </p:sp>
+      <p:sp>
+        <p:nvSpPr>
+          <p:cNvPr id="14" name="TextBox 13"/>
+          <p:cNvSpPr txBox="1"/>
+          <p:nvPr/>
+        </p:nvSpPr>
+        <p:spPr>
+          <a:xfrm>
+            <a:off x="8202167" y="1170432"/>
+            <a:ext cx="1929384" cy="246888"/>
+          </a:xfrm>
+          <a:prstGeom prst="rect">
+            <a:avLst/>
+          </a:prstGeom>
+          <a:noFill/>
+        </p:spPr>
+        <p:txBody>
+          <a:bodyPr wrap="none" lIns="45720" rIns="45720" anchor="t">
+            <a:spAutoFit/>
+          </a:bodyPr>
+          <a:lstStyle/>
+          <a:p>
+            <a:pPr algn="l"/>
+            <a:r>
+              <a:rPr sz="1220" b="1">
+                <a:solidFill>
+                  <a:srgbClr val="123447"/>
+                </a:solidFill>
+                <a:latin typeface="Aptos"/>
+              </a:rPr>
+              <a:t>Validation upgrade</a:t>
+            </a:r>
+          </a:p>
+        </p:txBody>
+      </p:sp>
+      <p:sp>
+        <p:nvSpPr>
+          <p:cNvPr id="15" name="TextBox 14"/>
+          <p:cNvSpPr txBox="1"/>
+          <p:nvPr/>
+        </p:nvSpPr>
+        <p:spPr>
+          <a:xfrm>
+            <a:off x="8202167" y="1463039"/>
+            <a:ext cx="1929384" cy="384048"/>
+          </a:xfrm>
+          <a:prstGeom prst="rect">
+            <a:avLst/>
+          </a:prstGeom>
+          <a:noFill/>
+        </p:spPr>
+        <p:txBody>
+          <a:bodyPr wrap="none" lIns="45720" rIns="45720" anchor="t">
+            <a:spAutoFit/>
+          </a:bodyPr>
+          <a:lstStyle/>
+          <a:p>
+            <a:pPr algn="l"/>
+            <a:r>
+              <a:rPr sz="890" b="0">
+                <a:solidFill>
+                  <a:srgbClr val="1F2933"/>
+                </a:solidFill>
+                <a:latin typeface="Aptos"/>
+              </a:rPr>
+              <a:t>complete-well holdout
+instead of random depth rows</a:t>
+            </a:r>
+          </a:p>
+        </p:txBody>
+      </p:sp>
+      <p:sp>
+        <p:nvSpPr>
+          <p:cNvPr id="16" name="Rounded Rectangle 15"/>
+          <p:cNvSpPr/>
+          <p:nvPr/>
+        </p:nvSpPr>
+        <p:spPr>
+          <a:xfrm>
+            <a:off x="685800" y="2267712"/>
+            <a:ext cx="1417320" cy="621792"/>
+          </a:xfrm>
+          <a:prstGeom prst="roundRect">
+            <a:avLst/>
+          </a:prstGeom>
+          <a:solidFill>
+            <a:srgbClr val="F4EFE6"/>
+          </a:solidFill>
+          <a:ln w="13970">
+            <a:solidFill>
+              <a:srgbClr val="167D8D"/>
+            </a:solidFill>
+          </a:ln>
+        </p:spPr>
+        <p:style>
+          <a:lnRef idx="1">
+            <a:schemeClr val="accent1"/>
+          </a:lnRef>
+          <a:fillRef idx="3">
+            <a:schemeClr val="accent1"/>
+          </a:fillRef>
+          <a:effectRef idx="2">
+            <a:schemeClr val="accent1"/>
+          </a:effectRef>
+          <a:fontRef idx="minor">
+            <a:schemeClr val="lt1"/>
+          </a:fontRef>
+        </p:style>
+        <p:txBody>
+          <a:bodyPr rtlCol="0" anchor="ctr"/>
+          <a:lstStyle/>
+          <a:p>
+            <a:pPr algn="ctr"/>
+          </a:p>
+        </p:txBody>
+      </p:sp>
+      <p:sp>
+        <p:nvSpPr>
+          <p:cNvPr id="17" name="TextBox 16"/>
+          <p:cNvSpPr txBox="1"/>
+          <p:nvPr/>
+        </p:nvSpPr>
+        <p:spPr>
+          <a:xfrm>
+            <a:off x="795528" y="2359152"/>
             <a:ext cx="1197864" cy="246888"/>
           </a:xfrm>
           <a:prstGeom prst="rect">
@@ -6234,21 +6469,21 @@
                 </a:solidFill>
                 <a:latin typeface="Aptos"/>
               </a:rPr>
-              <a:t>features</a:t>
+              <a:t>approved logs</a:t>
             </a:r>
           </a:p>
         </p:txBody>
       </p:sp>
       <p:cxnSp>
         <p:nvCxnSpPr>
-          <p:cNvPr id="12" name="Connector 11"/>
+          <p:cNvPr id="18" name="Connector 17"/>
           <p:cNvCxnSpPr/>
           <p:nvPr/>
         </p:nvCxnSpPr>
         <p:spPr>
           <a:xfrm>
-            <a:off x="5742431" y="1453896"/>
-            <a:ext cx="256033" cy="0"/>
+            <a:off x="2121408" y="2578608"/>
+            <a:ext cx="256031" cy="0"/>
           </a:xfrm>
           <a:prstGeom prst="line">
             <a:avLst/>
@@ -6276,13 +6511,13 @@
       </p:cxnSp>
       <p:sp>
         <p:nvSpPr>
-          <p:cNvPr id="13" name="Rounded Rectangle 12"/>
+          <p:cNvPr id="19" name="Rounded Rectangle 18"/>
           <p:cNvSpPr/>
           <p:nvPr/>
         </p:nvSpPr>
         <p:spPr>
           <a:xfrm>
-            <a:off x="6071616" y="1143000"/>
+            <a:off x="2450592" y="2267712"/>
             <a:ext cx="1417320" cy="621792"/>
           </a:xfrm>
           <a:prstGeom prst="roundRect">
@@ -6321,13 +6556,13 @@
       </p:sp>
       <p:sp>
         <p:nvSpPr>
-          <p:cNvPr id="14" name="TextBox 13"/>
-          <p:cNvSpPr txBox="1"/>
-          <p:nvPr/>
-        </p:nvSpPr>
-        <p:spPr>
-          <a:xfrm>
-            <a:off x="6181344" y="1234440"/>
+          <p:cNvPr id="20" name="TextBox 19"/>
+          <p:cNvSpPr txBox="1"/>
+          <p:nvPr/>
+        </p:nvSpPr>
+        <p:spPr>
+          <a:xfrm>
+            <a:off x="2560320" y="2359152"/>
             <a:ext cx="1197864" cy="246888"/>
           </a:xfrm>
           <a:prstGeom prst="rect">
@@ -6349,20 +6584,20 @@
                 </a:solidFill>
                 <a:latin typeface="Aptos"/>
               </a:rPr>
-              <a:t>labels</a:t>
+              <a:t>QC</a:t>
             </a:r>
           </a:p>
         </p:txBody>
       </p:sp>
       <p:cxnSp>
         <p:nvCxnSpPr>
-          <p:cNvPr id="15" name="Connector 14"/>
+          <p:cNvPr id="21" name="Connector 20"/>
           <p:cNvCxnSpPr/>
           <p:nvPr/>
         </p:nvCxnSpPr>
         <p:spPr>
           <a:xfrm>
-            <a:off x="7507224" y="1453896"/>
+            <a:off x="3886200" y="2578608"/>
             <a:ext cx="256032" cy="0"/>
           </a:xfrm>
           <a:prstGeom prst="line">
@@ -6391,13 +6626,13 @@
       </p:cxnSp>
       <p:sp>
         <p:nvSpPr>
-          <p:cNvPr id="16" name="Rounded Rectangle 15"/>
+          <p:cNvPr id="22" name="Rounded Rectangle 21"/>
           <p:cNvSpPr/>
           <p:nvPr/>
         </p:nvSpPr>
         <p:spPr>
           <a:xfrm>
-            <a:off x="7836408" y="1143000"/>
+            <a:off x="4215384" y="2267712"/>
             <a:ext cx="1417320" cy="621792"/>
           </a:xfrm>
           <a:prstGeom prst="roundRect">
@@ -6436,13 +6671,13 @@
       </p:sp>
       <p:sp>
         <p:nvSpPr>
-          <p:cNvPr id="17" name="TextBox 16"/>
-          <p:cNvSpPr txBox="1"/>
-          <p:nvPr/>
-        </p:nvSpPr>
-        <p:spPr>
-          <a:xfrm>
-            <a:off x="7946136" y="1234440"/>
+          <p:cNvPr id="23" name="TextBox 22"/>
+          <p:cNvSpPr txBox="1"/>
+          <p:nvPr/>
+        </p:nvSpPr>
+        <p:spPr>
+          <a:xfrm>
+            <a:off x="4325112" y="2359152"/>
             <a:ext cx="1197864" cy="246888"/>
           </a:xfrm>
           <a:prstGeom prst="rect">
@@ -6464,20 +6699,20 @@
                 </a:solidFill>
                 <a:latin typeface="Aptos"/>
               </a:rPr>
-              <a:t>models</a:t>
+              <a:t>feature sets</a:t>
             </a:r>
           </a:p>
         </p:txBody>
       </p:sp>
       <p:cxnSp>
         <p:nvCxnSpPr>
-          <p:cNvPr id="18" name="Connector 17"/>
+          <p:cNvPr id="24" name="Connector 23"/>
           <p:cNvCxnSpPr/>
           <p:nvPr/>
         </p:nvCxnSpPr>
         <p:spPr>
           <a:xfrm>
-            <a:off x="9272016" y="1453896"/>
+            <a:off x="5650992" y="2578608"/>
             <a:ext cx="256032" cy="0"/>
           </a:xfrm>
           <a:prstGeom prst="line">
@@ -6506,13 +6741,243 @@
       </p:cxnSp>
       <p:sp>
         <p:nvSpPr>
-          <p:cNvPr id="19" name="Rounded Rectangle 18"/>
+          <p:cNvPr id="25" name="Rounded Rectangle 24"/>
           <p:cNvSpPr/>
           <p:nvPr/>
         </p:nvSpPr>
         <p:spPr>
           <a:xfrm>
-            <a:off x="9601200" y="1143000"/>
+            <a:off x="5980176" y="2267712"/>
+            <a:ext cx="1417320" cy="621792"/>
+          </a:xfrm>
+          <a:prstGeom prst="roundRect">
+            <a:avLst/>
+          </a:prstGeom>
+          <a:solidFill>
+            <a:srgbClr val="EAF5F6"/>
+          </a:solidFill>
+          <a:ln w="13970">
+            <a:solidFill>
+              <a:srgbClr val="167D8D"/>
+            </a:solidFill>
+          </a:ln>
+        </p:spPr>
+        <p:style>
+          <a:lnRef idx="1">
+            <a:schemeClr val="accent1"/>
+          </a:lnRef>
+          <a:fillRef idx="3">
+            <a:schemeClr val="accent1"/>
+          </a:fillRef>
+          <a:effectRef idx="2">
+            <a:schemeClr val="accent1"/>
+          </a:effectRef>
+          <a:fontRef idx="minor">
+            <a:schemeClr val="lt1"/>
+          </a:fontRef>
+        </p:style>
+        <p:txBody>
+          <a:bodyPr rtlCol="0" anchor="ctr"/>
+          <a:lstStyle/>
+          <a:p>
+            <a:pPr algn="ctr"/>
+          </a:p>
+        </p:txBody>
+      </p:sp>
+      <p:sp>
+        <p:nvSpPr>
+          <p:cNvPr id="26" name="TextBox 25"/>
+          <p:cNvSpPr txBox="1"/>
+          <p:nvPr/>
+        </p:nvSpPr>
+        <p:spPr>
+          <a:xfrm>
+            <a:off x="6089904" y="2359152"/>
+            <a:ext cx="1197864" cy="246888"/>
+          </a:xfrm>
+          <a:prstGeom prst="rect">
+            <a:avLst/>
+          </a:prstGeom>
+          <a:noFill/>
+        </p:spPr>
+        <p:txBody>
+          <a:bodyPr wrap="none" lIns="45720" rIns="45720" anchor="t">
+            <a:spAutoFit/>
+          </a:bodyPr>
+          <a:lstStyle/>
+          <a:p>
+            <a:pPr algn="l"/>
+            <a:r>
+              <a:rPr sz="1220" b="1">
+                <a:solidFill>
+                  <a:srgbClr val="123447"/>
+                </a:solidFill>
+                <a:latin typeface="Aptos"/>
+              </a:rPr>
+              <a:t>model ladder</a:t>
+            </a:r>
+          </a:p>
+        </p:txBody>
+      </p:sp>
+      <p:cxnSp>
+        <p:nvCxnSpPr>
+          <p:cNvPr id="27" name="Connector 26"/>
+          <p:cNvCxnSpPr/>
+          <p:nvPr/>
+        </p:nvCxnSpPr>
+        <p:spPr>
+          <a:xfrm>
+            <a:off x="7415784" y="2578608"/>
+            <a:ext cx="256032" cy="0"/>
+          </a:xfrm>
+          <a:prstGeom prst="line">
+            <a:avLst/>
+          </a:prstGeom>
+          <a:ln w="25400">
+            <a:solidFill>
+              <a:srgbClr val="167D8D"/>
+            </a:solidFill>
+          </a:ln>
+        </p:spPr>
+        <p:style>
+          <a:lnRef idx="2">
+            <a:schemeClr val="accent1"/>
+          </a:lnRef>
+          <a:fillRef idx="0">
+            <a:schemeClr val="accent1"/>
+          </a:fillRef>
+          <a:effectRef idx="1">
+            <a:schemeClr val="accent1"/>
+          </a:effectRef>
+          <a:fontRef idx="minor">
+            <a:schemeClr val="tx1"/>
+          </a:fontRef>
+        </p:style>
+      </p:cxnSp>
+      <p:sp>
+        <p:nvSpPr>
+          <p:cNvPr id="28" name="Rounded Rectangle 27"/>
+          <p:cNvSpPr/>
+          <p:nvPr/>
+        </p:nvSpPr>
+        <p:spPr>
+          <a:xfrm>
+            <a:off x="7744968" y="2267712"/>
+            <a:ext cx="1417320" cy="621792"/>
+          </a:xfrm>
+          <a:prstGeom prst="roundRect">
+            <a:avLst/>
+          </a:prstGeom>
+          <a:solidFill>
+            <a:srgbClr val="EAF5F6"/>
+          </a:solidFill>
+          <a:ln w="13970">
+            <a:solidFill>
+              <a:srgbClr val="167D8D"/>
+            </a:solidFill>
+          </a:ln>
+        </p:spPr>
+        <p:style>
+          <a:lnRef idx="1">
+            <a:schemeClr val="accent1"/>
+          </a:lnRef>
+          <a:fillRef idx="3">
+            <a:schemeClr val="accent1"/>
+          </a:fillRef>
+          <a:effectRef idx="2">
+            <a:schemeClr val="accent1"/>
+          </a:effectRef>
+          <a:fontRef idx="minor">
+            <a:schemeClr val="lt1"/>
+          </a:fontRef>
+        </p:style>
+        <p:txBody>
+          <a:bodyPr rtlCol="0" anchor="ctr"/>
+          <a:lstStyle/>
+          <a:p>
+            <a:pPr algn="ctr"/>
+          </a:p>
+        </p:txBody>
+      </p:sp>
+      <p:sp>
+        <p:nvSpPr>
+          <p:cNvPr id="29" name="TextBox 28"/>
+          <p:cNvSpPr txBox="1"/>
+          <p:nvPr/>
+        </p:nvSpPr>
+        <p:spPr>
+          <a:xfrm>
+            <a:off x="7854696" y="2359152"/>
+            <a:ext cx="1197864" cy="246888"/>
+          </a:xfrm>
+          <a:prstGeom prst="rect">
+            <a:avLst/>
+          </a:prstGeom>
+          <a:noFill/>
+        </p:spPr>
+        <p:txBody>
+          <a:bodyPr wrap="none" lIns="45720" rIns="45720" anchor="t">
+            <a:spAutoFit/>
+          </a:bodyPr>
+          <a:lstStyle/>
+          <a:p>
+            <a:pPr algn="l"/>
+            <a:r>
+              <a:rPr sz="1220" b="1">
+                <a:solidFill>
+                  <a:srgbClr val="123447"/>
+                </a:solidFill>
+                <a:latin typeface="Aptos"/>
+              </a:rPr>
+              <a:t>held-out wells</a:t>
+            </a:r>
+          </a:p>
+        </p:txBody>
+      </p:sp>
+      <p:cxnSp>
+        <p:nvCxnSpPr>
+          <p:cNvPr id="30" name="Connector 29"/>
+          <p:cNvCxnSpPr/>
+          <p:nvPr/>
+        </p:nvCxnSpPr>
+        <p:spPr>
+          <a:xfrm>
+            <a:off x="9180576" y="2578608"/>
+            <a:ext cx="256032" cy="0"/>
+          </a:xfrm>
+          <a:prstGeom prst="line">
+            <a:avLst/>
+          </a:prstGeom>
+          <a:ln w="25400">
+            <a:solidFill>
+              <a:srgbClr val="167D8D"/>
+            </a:solidFill>
+          </a:ln>
+        </p:spPr>
+        <p:style>
+          <a:lnRef idx="2">
+            <a:schemeClr val="accent1"/>
+          </a:lnRef>
+          <a:fillRef idx="0">
+            <a:schemeClr val="accent1"/>
+          </a:fillRef>
+          <a:effectRef idx="1">
+            <a:schemeClr val="accent1"/>
+          </a:effectRef>
+          <a:fontRef idx="minor">
+            <a:schemeClr val="tx1"/>
+          </a:fontRef>
+        </p:style>
+      </p:cxnSp>
+      <p:sp>
+        <p:nvSpPr>
+          <p:cNvPr id="31" name="Rounded Rectangle 30"/>
+          <p:cNvSpPr/>
+          <p:nvPr/>
+        </p:nvSpPr>
+        <p:spPr>
+          <a:xfrm>
+            <a:off x="9509760" y="2267712"/>
             <a:ext cx="1417320" cy="621792"/>
           </a:xfrm>
           <a:prstGeom prst="roundRect">
@@ -6551,13 +7016,13 @@
       </p:sp>
       <p:sp>
         <p:nvSpPr>
-          <p:cNvPr id="20" name="TextBox 19"/>
-          <p:cNvSpPr txBox="1"/>
-          <p:nvPr/>
-        </p:nvSpPr>
-        <p:spPr>
-          <a:xfrm>
-            <a:off x="9710928" y="1234440"/>
+          <p:cNvPr id="32" name="TextBox 31"/>
+          <p:cNvSpPr txBox="1"/>
+          <p:nvPr/>
+        </p:nvSpPr>
+        <p:spPr>
+          <a:xfrm>
+            <a:off x="9619488" y="2359152"/>
             <a:ext cx="1197864" cy="246888"/>
           </a:xfrm>
           <a:prstGeom prst="rect">
@@ -6579,21 +7044,21 @@
                 </a:solidFill>
                 <a:latin typeface="Aptos"/>
               </a:rPr>
-              <a:t>validation</a:t>
-            </a:r>
-          </a:p>
-        </p:txBody>
-      </p:sp>
-      <p:sp>
-        <p:nvSpPr>
-          <p:cNvPr id="21" name="Rounded Rectangle 20"/>
+              <a:t>outputs</a:t>
+            </a:r>
+          </a:p>
+        </p:txBody>
+      </p:sp>
+      <p:sp>
+        <p:nvSpPr>
+          <p:cNvPr id="33" name="Rounded Rectangle 32"/>
           <p:cNvSpPr/>
           <p:nvPr/>
         </p:nvSpPr>
         <p:spPr>
           <a:xfrm>
-            <a:off x="868680" y="2468880"/>
-            <a:ext cx="2834640" cy="1234440"/>
+            <a:off x="685800" y="3429000"/>
+            <a:ext cx="2697480" cy="1051560"/>
           </a:xfrm>
           <a:prstGeom prst="roundRect">
             <a:avLst/>
@@ -6631,14 +7096,14 @@
       </p:sp>
       <p:sp>
         <p:nvSpPr>
-          <p:cNvPr id="22" name="TextBox 21"/>
-          <p:cNvSpPr txBox="1"/>
-          <p:nvPr/>
-        </p:nvSpPr>
-        <p:spPr>
-          <a:xfrm>
-            <a:off x="978407" y="2560320"/>
-            <a:ext cx="2615184" cy="246888"/>
+          <p:cNvPr id="34" name="TextBox 33"/>
+          <p:cNvSpPr txBox="1"/>
+          <p:nvPr/>
+        </p:nvSpPr>
+        <p:spPr>
+          <a:xfrm>
+            <a:off x="795528" y="3520440"/>
+            <a:ext cx="2478024" cy="246888"/>
           </a:xfrm>
           <a:prstGeom prst="rect">
             <a:avLst/>
@@ -6659,21 +7124,21 @@
                 </a:solidFill>
                 <a:latin typeface="Aptos"/>
               </a:rPr>
-              <a:t>Data processing</a:t>
-            </a:r>
-          </a:p>
-        </p:txBody>
-      </p:sp>
-      <p:sp>
-        <p:nvSpPr>
-          <p:cNvPr id="23" name="TextBox 22"/>
-          <p:cNvSpPr txBox="1"/>
-          <p:nvPr/>
-        </p:nvSpPr>
-        <p:spPr>
-          <a:xfrm>
-            <a:off x="978407" y="2852928"/>
-            <a:ext cx="2615184" cy="795528"/>
+              <a:t>1. QC and alignment</a:t>
+            </a:r>
+          </a:p>
+        </p:txBody>
+      </p:sp>
+      <p:sp>
+        <p:nvSpPr>
+          <p:cNvPr id="35" name="TextBox 34"/>
+          <p:cNvSpPr txBox="1"/>
+          <p:nvPr/>
+        </p:nvSpPr>
+        <p:spPr>
+          <a:xfrm>
+            <a:off x="795528" y="3813048"/>
+            <a:ext cx="2478024" cy="612647"/>
           </a:xfrm>
           <a:prstGeom prst="rect">
             <a:avLst/>
@@ -6694,21 +7159,21 @@
                 </a:solidFill>
                 <a:latin typeface="Aptos"/>
               </a:rPr>
-              <a:t>Remove outliers, select depth intervals, align logs and core, and standardize units.</a:t>
-            </a:r>
-          </a:p>
-        </p:txBody>
-      </p:sp>
-      <p:sp>
-        <p:nvSpPr>
-          <p:cNvPr id="24" name="Rounded Rectangle 23"/>
+              <a:t>Caliper washout, depth matching, missing-curve routing, unit standardization, multivariate outlier review.</a:t>
+            </a:r>
+          </a:p>
+        </p:txBody>
+      </p:sp>
+      <p:sp>
+        <p:nvSpPr>
+          <p:cNvPr id="36" name="Rounded Rectangle 35"/>
           <p:cNvSpPr/>
           <p:nvPr/>
         </p:nvSpPr>
         <p:spPr>
           <a:xfrm>
-            <a:off x="3977639" y="2468880"/>
-            <a:ext cx="2834640" cy="1234440"/>
+            <a:off x="3611880" y="3429000"/>
+            <a:ext cx="2697480" cy="1051560"/>
           </a:xfrm>
           <a:prstGeom prst="roundRect">
             <a:avLst/>
@@ -6746,14 +7211,14 @@
       </p:sp>
       <p:sp>
         <p:nvSpPr>
-          <p:cNvPr id="25" name="TextBox 24"/>
-          <p:cNvSpPr txBox="1"/>
-          <p:nvPr/>
-        </p:nvSpPr>
-        <p:spPr>
-          <a:xfrm>
-            <a:off x="4087368" y="2560320"/>
-            <a:ext cx="2615184" cy="246888"/>
+          <p:cNvPr id="37" name="TextBox 36"/>
+          <p:cNvSpPr txBox="1"/>
+          <p:nvPr/>
+        </p:nvSpPr>
+        <p:spPr>
+          <a:xfrm>
+            <a:off x="3721608" y="3520440"/>
+            <a:ext cx="2478024" cy="246888"/>
           </a:xfrm>
           <a:prstGeom prst="rect">
             <a:avLst/>
@@ -6774,21 +7239,21 @@
                 </a:solidFill>
                 <a:latin typeface="Aptos"/>
               </a:rPr>
-              <a:t>Modeling</a:t>
-            </a:r>
-          </a:p>
-        </p:txBody>
-      </p:sp>
-      <p:sp>
-        <p:nvSpPr>
-          <p:cNvPr id="26" name="TextBox 25"/>
-          <p:cNvSpPr txBox="1"/>
-          <p:nvPr/>
-        </p:nvSpPr>
-        <p:spPr>
-          <a:xfrm>
-            <a:off x="4087368" y="2852928"/>
-            <a:ext cx="2615184" cy="795528"/>
+              <a:t>2. Physics features</a:t>
+            </a:r>
+          </a:p>
+        </p:txBody>
+      </p:sp>
+      <p:sp>
+        <p:nvSpPr>
+          <p:cNvPr id="38" name="TextBox 37"/>
+          <p:cNvSpPr txBox="1"/>
+          <p:nvPr/>
+        </p:nvSpPr>
+        <p:spPr>
+          <a:xfrm>
+            <a:off x="3721608" y="3813048"/>
+            <a:ext cx="2478024" cy="612647"/>
           </a:xfrm>
           <a:prstGeom prst="rect">
             <a:avLst/>
@@ -6809,21 +7274,21 @@
                 </a:solidFill>
                 <a:latin typeface="Aptos"/>
               </a:rPr>
-              <a:t>Compare rules, linear baselines, tree models, and Keras/ANN saturation models.</a:t>
-            </a:r>
-          </a:p>
-        </p:txBody>
-      </p:sp>
-      <p:sp>
-        <p:nvSpPr>
-          <p:cNvPr id="27" name="Rounded Rectangle 26"/>
+              <a:t>Separate measured logs, derived elastic/geomechanical features, and target-derived saturation fields.</a:t>
+            </a:r>
+          </a:p>
+        </p:txBody>
+      </p:sp>
+      <p:sp>
+        <p:nvSpPr>
+          <p:cNvPr id="39" name="Rounded Rectangle 38"/>
           <p:cNvSpPr/>
           <p:nvPr/>
         </p:nvSpPr>
         <p:spPr>
           <a:xfrm>
-            <a:off x="7086600" y="2468880"/>
-            <a:ext cx="2834640" cy="1234440"/>
+            <a:off x="6537960" y="3429000"/>
+            <a:ext cx="2697480" cy="1051560"/>
           </a:xfrm>
           <a:prstGeom prst="roundRect">
             <a:avLst/>
@@ -6861,14 +7326,14 @@
       </p:sp>
       <p:sp>
         <p:nvSpPr>
-          <p:cNvPr id="28" name="TextBox 27"/>
-          <p:cNvSpPr txBox="1"/>
-          <p:nvPr/>
-        </p:nvSpPr>
-        <p:spPr>
-          <a:xfrm>
-            <a:off x="7196328" y="2560320"/>
-            <a:ext cx="2615184" cy="246888"/>
+          <p:cNvPr id="40" name="TextBox 39"/>
+          <p:cNvSpPr txBox="1"/>
+          <p:nvPr/>
+        </p:nvSpPr>
+        <p:spPr>
+          <a:xfrm>
+            <a:off x="6647688" y="3520440"/>
+            <a:ext cx="2478024" cy="246888"/>
           </a:xfrm>
           <a:prstGeom prst="rect">
             <a:avLst/>
@@ -6889,21 +7354,21 @@
                 </a:solidFill>
                 <a:latin typeface="Aptos"/>
               </a:rPr>
-              <a:t>Validation</a:t>
-            </a:r>
-          </a:p>
-        </p:txBody>
-      </p:sp>
-      <p:sp>
-        <p:nvSpPr>
-          <p:cNvPr id="29" name="TextBox 28"/>
-          <p:cNvSpPr txBox="1"/>
-          <p:nvPr/>
-        </p:nvSpPr>
-        <p:spPr>
-          <a:xfrm>
-            <a:off x="7196328" y="2852928"/>
-            <a:ext cx="2615184" cy="795528"/>
+              <a:t>3. Model ladder</a:t>
+            </a:r>
+          </a:p>
+        </p:txBody>
+      </p:sp>
+      <p:sp>
+        <p:nvSpPr>
+          <p:cNvPr id="41" name="TextBox 40"/>
+          <p:cNvSpPr txBox="1"/>
+          <p:nvPr/>
+        </p:nvSpPr>
+        <p:spPr>
+          <a:xfrm>
+            <a:off x="6647688" y="3813048"/>
+            <a:ext cx="2478024" cy="612647"/>
           </a:xfrm>
           <a:prstGeom prst="rect">
             <a:avLst/>
@@ -6924,14 +7389,131 @@
                 </a:solidFill>
                 <a:latin typeface="Aptos"/>
               </a:rPr>
-              <a:t>Use complete-well holdouts and compare predictions against core and interpreted measurements.</a:t>
+              <a:t>Rules and linear baselines first; tree/GBM for feature behavior; ANN/Keras for nonlinear saturation response.</a:t>
+            </a:r>
+          </a:p>
+        </p:txBody>
+      </p:sp>
+      <p:sp>
+        <p:nvSpPr>
+          <p:cNvPr id="42" name="Rounded Rectangle 41"/>
+          <p:cNvSpPr/>
+          <p:nvPr/>
+        </p:nvSpPr>
+        <p:spPr>
+          <a:xfrm>
+            <a:off x="9464040" y="3429000"/>
+            <a:ext cx="2011680" cy="1051560"/>
+          </a:xfrm>
+          <a:prstGeom prst="roundRect">
+            <a:avLst/>
+          </a:prstGeom>
+          <a:solidFill>
+            <a:srgbClr val="EAF5F6"/>
+          </a:solidFill>
+          <a:ln w="13970">
+            <a:solidFill>
+              <a:srgbClr val="167D8D"/>
+            </a:solidFill>
+          </a:ln>
+        </p:spPr>
+        <p:style>
+          <a:lnRef idx="1">
+            <a:schemeClr val="accent1"/>
+          </a:lnRef>
+          <a:fillRef idx="3">
+            <a:schemeClr val="accent1"/>
+          </a:fillRef>
+          <a:effectRef idx="2">
+            <a:schemeClr val="accent1"/>
+          </a:effectRef>
+          <a:fontRef idx="minor">
+            <a:schemeClr val="lt1"/>
+          </a:fontRef>
+        </p:style>
+        <p:txBody>
+          <a:bodyPr rtlCol="0" anchor="ctr"/>
+          <a:lstStyle/>
+          <a:p>
+            <a:pPr algn="ctr"/>
+          </a:p>
+        </p:txBody>
+      </p:sp>
+      <p:sp>
+        <p:nvSpPr>
+          <p:cNvPr id="43" name="TextBox 42"/>
+          <p:cNvSpPr txBox="1"/>
+          <p:nvPr/>
+        </p:nvSpPr>
+        <p:spPr>
+          <a:xfrm>
+            <a:off x="9573767" y="3520440"/>
+            <a:ext cx="1792224" cy="246888"/>
+          </a:xfrm>
+          <a:prstGeom prst="rect">
+            <a:avLst/>
+          </a:prstGeom>
+          <a:noFill/>
+        </p:spPr>
+        <p:txBody>
+          <a:bodyPr wrap="none" lIns="45720" rIns="45720" anchor="t">
+            <a:spAutoFit/>
+          </a:bodyPr>
+          <a:lstStyle/>
+          <a:p>
+            <a:pPr algn="l"/>
+            <a:r>
+              <a:rPr sz="1220" b="1">
+                <a:solidFill>
+                  <a:srgbClr val="123447"/>
+                </a:solidFill>
+                <a:latin typeface="Aptos"/>
+              </a:rPr>
+              <a:t>4. Outputs</a:t>
+            </a:r>
+          </a:p>
+        </p:txBody>
+      </p:sp>
+      <p:sp>
+        <p:nvSpPr>
+          <p:cNvPr id="44" name="TextBox 43"/>
+          <p:cNvSpPr txBox="1"/>
+          <p:nvPr/>
+        </p:nvSpPr>
+        <p:spPr>
+          <a:xfrm>
+            <a:off x="9573767" y="3813048"/>
+            <a:ext cx="1792224" cy="612647"/>
+          </a:xfrm>
+          <a:prstGeom prst="rect">
+            <a:avLst/>
+          </a:prstGeom>
+          <a:noFill/>
+        </p:spPr>
+        <p:txBody>
+          <a:bodyPr wrap="none" lIns="45720" rIns="45720" anchor="t">
+            <a:spAutoFit/>
+          </a:bodyPr>
+          <a:lstStyle/>
+          <a:p>
+            <a:pPr algn="l"/>
+            <a:r>
+              <a:rPr sz="890" b="0">
+                <a:solidFill>
+                  <a:srgbClr val="1F2933"/>
+                </a:solidFill>
+                <a:latin typeface="Aptos"/>
+              </a:rPr>
+              <a:t>Occurrence class
+Sh regression
+uncertainty flags</a:t>
             </a:r>
           </a:p>
         </p:txBody>
       </p:sp>
       <p:pic>
         <p:nvPicPr>
-          <p:cNvPr id="30" name="Picture 29" descr="model_validation_placeholders.png"/>
+          <p:cNvPr id="45" name="Picture 44" descr="model_validation_placeholders.png"/>
           <p:cNvPicPr>
             <a:picLocks noChangeAspect="1"/>
           </p:cNvPicPr>
@@ -6945,8 +7527,8 @@
         </p:blipFill>
         <p:spPr>
           <a:xfrm>
-            <a:off x="1828800" y="4069080"/>
-            <a:ext cx="8641080" cy="1508760"/>
+            <a:off x="2057400" y="4873752"/>
+            <a:ext cx="8046720" cy="1078992"/>
           </a:xfrm>
           <a:prstGeom prst="rect">
             <a:avLst/>
@@ -6955,7 +7537,7 @@
       </p:pic>
       <p:sp>
         <p:nvSpPr>
-          <p:cNvPr id="31" name="TextBox 30"/>
+          <p:cNvPr id="46" name="TextBox 45"/>
           <p:cNvSpPr txBox="1"/>
           <p:nvPr/>
         </p:nvSpPr>
@@ -6983,7 +7565,7 @@
                 </a:solidFill>
                 <a:latin typeface="Aptos"/>
               </a:rPr>
-              <a:t>Source anchor: Chong et al. 2022; project runtime requirements map.</a:t>
+              <a:t>Source anchor: Chong et al. 2022, DOI: 10.1007/s10596-022-10151-9; project runtime requirements map.</a:t>
             </a:r>
           </a:p>
         </p:txBody>
@@ -7036,7 +7618,7 @@
                 </a:solidFill>
                 <a:latin typeface="Aptos"/>
               </a:rPr>
-              <a:t>ML Methodology: Why These Parameters</a:t>
+              <a:t>ML Methodology: Why This Architecture Fits Well Logs</a:t>
             </a:r>
           </a:p>
         </p:txBody>
@@ -7071,7 +7653,7 @@
                 </a:solidFill>
                 <a:latin typeface="Aptos"/>
               </a:rPr>
-              <a:t>Classification and regression need different evidence</a:t>
+              <a:t>Depth-indexed curves need both explainable baselines and nonlinear models</a:t>
             </a:r>
           </a:p>
         </p:txBody>
@@ -7092,8 +7674,8 @@
         </p:blipFill>
         <p:spPr>
           <a:xfrm>
-            <a:off x="5897880" y="1051560"/>
-            <a:ext cx="5440680" cy="2743200"/>
+            <a:off x="6400800" y="1078992"/>
+            <a:ext cx="4892040" cy="2423160"/>
           </a:xfrm>
           <a:prstGeom prst="rect">
             <a:avLst/>
@@ -7108,8 +7690,8 @@
         </p:nvSpPr>
         <p:spPr>
           <a:xfrm>
-            <a:off x="731520" y="1170432"/>
-            <a:ext cx="4572000" cy="914400"/>
+            <a:off x="685800" y="1143000"/>
+            <a:ext cx="2514600" cy="914400"/>
           </a:xfrm>
           <a:prstGeom prst="roundRect">
             <a:avLst/>
@@ -7153,8 +7735,8 @@
         </p:nvSpPr>
         <p:spPr>
           <a:xfrm>
-            <a:off x="841248" y="1261872"/>
-            <a:ext cx="4352544" cy="246888"/>
+            <a:off x="795528" y="1234440"/>
+            <a:ext cx="2295144" cy="246888"/>
           </a:xfrm>
           <a:prstGeom prst="rect">
             <a:avLst/>
@@ -7175,7 +7757,7 @@
                 </a:solidFill>
                 <a:latin typeface="Aptos"/>
               </a:rPr>
-              <a:t>Classification</a:t>
+              <a:t>Classification branch</a:t>
             </a:r>
           </a:p>
         </p:txBody>
@@ -7188,8 +7770,8 @@
         </p:nvSpPr>
         <p:spPr>
           <a:xfrm>
-            <a:off x="841248" y="1554480"/>
-            <a:ext cx="4352544" cy="475488"/>
+            <a:off x="795528" y="1527048"/>
+            <a:ext cx="2295144" cy="475488"/>
           </a:xfrm>
           <a:prstGeom prst="rect">
             <a:avLst/>
@@ -7210,7 +7792,7 @@
                 </a:solidFill>
                 <a:latin typeface="Aptos"/>
               </a:rPr>
-              <a:t>Predict hydrate occurrence or phase class using lithology, resistivity, elastic, NMR, and QC context.</a:t>
+              <a:t>Detect hydrate-supportive intervals or phase classes from multi-log agreement, lithology, and QC context.</a:t>
             </a:r>
           </a:p>
         </p:txBody>
@@ -7223,8 +7805,8 @@
         </p:nvSpPr>
         <p:spPr>
           <a:xfrm>
-            <a:off x="731520" y="2395728"/>
-            <a:ext cx="4572000" cy="914400"/>
+            <a:off x="3429000" y="1143000"/>
+            <a:ext cx="2514600" cy="914400"/>
           </a:xfrm>
           <a:prstGeom prst="roundRect">
             <a:avLst/>
@@ -7268,8 +7850,8 @@
         </p:nvSpPr>
         <p:spPr>
           <a:xfrm>
-            <a:off x="841248" y="2487168"/>
-            <a:ext cx="4352544" cy="246888"/>
+            <a:off x="3538728" y="1234440"/>
+            <a:ext cx="2295144" cy="246888"/>
           </a:xfrm>
           <a:prstGeom prst="rect">
             <a:avLst/>
@@ -7290,7 +7872,7 @@
                 </a:solidFill>
                 <a:latin typeface="Aptos"/>
               </a:rPr>
-              <a:t>Regression</a:t>
+              <a:t>Regression branch</a:t>
             </a:r>
           </a:p>
         </p:txBody>
@@ -7303,8 +7885,8 @@
         </p:nvSpPr>
         <p:spPr>
           <a:xfrm>
-            <a:off x="841248" y="2779776"/>
-            <a:ext cx="4352544" cy="475488"/>
+            <a:off x="3538728" y="1527048"/>
+            <a:ext cx="2295144" cy="475488"/>
           </a:xfrm>
           <a:prstGeom prst="rect">
             <a:avLst/>
@@ -7325,7 +7907,7 @@
                 </a:solidFill>
                 <a:latin typeface="Aptos"/>
               </a:rPr>
-              <a:t>Predict continuous hydrate saturation from calibrated logs, NMR-derived or core-calibrated targets, and physics features.</a:t>
+              <a:t>Estimate continuous hydrate saturation only from allowed predictors and calibrated targets.</a:t>
             </a:r>
           </a:p>
         </p:txBody>
@@ -7338,8 +7920,8 @@
         </p:nvSpPr>
         <p:spPr>
           <a:xfrm>
-            <a:off x="731520" y="3621024"/>
-            <a:ext cx="4572000" cy="914400"/>
+            <a:off x="685800" y="2450592"/>
+            <a:ext cx="2514600" cy="914400"/>
           </a:xfrm>
           <a:prstGeom prst="roundRect">
             <a:avLst/>
@@ -7383,8 +7965,8 @@
         </p:nvSpPr>
         <p:spPr>
           <a:xfrm>
-            <a:off x="841248" y="3712463"/>
-            <a:ext cx="4352544" cy="246888"/>
+            <a:off x="795528" y="2542032"/>
+            <a:ext cx="2295144" cy="246888"/>
           </a:xfrm>
           <a:prstGeom prst="rect">
             <a:avLst/>
@@ -7405,7 +7987,7 @@
                 </a:solidFill>
                 <a:latin typeface="Aptos"/>
               </a:rPr>
-              <a:t>Linear vs nonlinear</a:t>
+              <a:t>Linear baseline</a:t>
             </a:r>
           </a:p>
         </p:txBody>
@@ -7418,8 +8000,8 @@
         </p:nvSpPr>
         <p:spPr>
           <a:xfrm>
-            <a:off x="841248" y="4005072"/>
-            <a:ext cx="4352544" cy="475488"/>
+            <a:off x="795528" y="2834640"/>
+            <a:ext cx="2295144" cy="475488"/>
           </a:xfrm>
           <a:prstGeom prst="rect">
             <a:avLst/>
@@ -7440,7 +8022,7 @@
                 </a:solidFill>
                 <a:latin typeface="Aptos"/>
               </a:rPr>
-              <a:t>Linear baselines show traceable relationships; nonlinear models test interactions among reservoir, electrical, elastic, and NMR evidence.</a:t>
+              <a:t>Shows defensible directionality and exposes whether a simple relation is already sufficient.</a:t>
             </a:r>
           </a:p>
         </p:txBody>
@@ -7453,8 +8035,8 @@
         </p:nvSpPr>
         <p:spPr>
           <a:xfrm>
-            <a:off x="6080760" y="4224528"/>
-            <a:ext cx="5074920" cy="841248"/>
+            <a:off x="3429000" y="2450592"/>
+            <a:ext cx="2514600" cy="914400"/>
           </a:xfrm>
           <a:prstGeom prst="roundRect">
             <a:avLst/>
@@ -7498,8 +8080,8 @@
         </p:nvSpPr>
         <p:spPr>
           <a:xfrm>
-            <a:off x="6190488" y="4315968"/>
-            <a:ext cx="4855464" cy="246888"/>
+            <a:off x="3538728" y="2542032"/>
+            <a:ext cx="2295144" cy="246888"/>
           </a:xfrm>
           <a:prstGeom prst="rect">
             <a:avLst/>
@@ -7520,7 +8102,7 @@
                 </a:solidFill>
                 <a:latin typeface="Aptos"/>
               </a:rPr>
-              <a:t>Website ranking logic</a:t>
+              <a:t>Tree/GBM test</a:t>
             </a:r>
           </a:p>
         </p:txBody>
@@ -7533,8 +8115,8 @@
         </p:nvSpPr>
         <p:spPr>
           <a:xfrm>
-            <a:off x="6190488" y="4608576"/>
-            <a:ext cx="4855464" cy="402336"/>
+            <a:off x="3538728" y="2834640"/>
+            <a:ext cx="2295144" cy="475488"/>
           </a:xfrm>
           <a:prstGeom prst="rect">
             <a:avLst/>
@@ -7555,14 +8137,359 @@
                 </a:solidFill>
                 <a:latin typeface="Aptos"/>
               </a:rPr>
-              <a:t>The sweet-spot ranking is an explainable scaffold, not a final result until approved data are run.</a:t>
-            </a:r>
-          </a:p>
-        </p:txBody>
-      </p:sp>
-      <p:sp>
-        <p:nvSpPr>
-          <p:cNvPr id="17" name="TextBox 16"/>
+              <a:t>Handles missingness and ranks feature importance without forcing a single curve relationship.</a:t>
+            </a:r>
+          </a:p>
+        </p:txBody>
+      </p:sp>
+      <p:sp>
+        <p:nvSpPr>
+          <p:cNvPr id="17" name="Rounded Rectangle 16"/>
+          <p:cNvSpPr/>
+          <p:nvPr/>
+        </p:nvSpPr>
+        <p:spPr>
+          <a:xfrm>
+            <a:off x="685800" y="3749039"/>
+            <a:ext cx="2514600" cy="914400"/>
+          </a:xfrm>
+          <a:prstGeom prst="roundRect">
+            <a:avLst/>
+          </a:prstGeom>
+          <a:solidFill>
+            <a:srgbClr val="EAF5F6"/>
+          </a:solidFill>
+          <a:ln w="13970">
+            <a:solidFill>
+              <a:srgbClr val="167D8D"/>
+            </a:solidFill>
+          </a:ln>
+        </p:spPr>
+        <p:style>
+          <a:lnRef idx="1">
+            <a:schemeClr val="accent1"/>
+          </a:lnRef>
+          <a:fillRef idx="3">
+            <a:schemeClr val="accent1"/>
+          </a:fillRef>
+          <a:effectRef idx="2">
+            <a:schemeClr val="accent1"/>
+          </a:effectRef>
+          <a:fontRef idx="minor">
+            <a:schemeClr val="lt1"/>
+          </a:fontRef>
+        </p:style>
+        <p:txBody>
+          <a:bodyPr rtlCol="0" anchor="ctr"/>
+          <a:lstStyle/>
+          <a:p>
+            <a:pPr algn="ctr"/>
+          </a:p>
+        </p:txBody>
+      </p:sp>
+      <p:sp>
+        <p:nvSpPr>
+          <p:cNvPr id="18" name="TextBox 17"/>
+          <p:cNvSpPr txBox="1"/>
+          <p:nvPr/>
+        </p:nvSpPr>
+        <p:spPr>
+          <a:xfrm>
+            <a:off x="795528" y="3840479"/>
+            <a:ext cx="2295144" cy="246888"/>
+          </a:xfrm>
+          <a:prstGeom prst="rect">
+            <a:avLst/>
+          </a:prstGeom>
+          <a:noFill/>
+        </p:spPr>
+        <p:txBody>
+          <a:bodyPr wrap="none" lIns="45720" rIns="45720" anchor="t">
+            <a:spAutoFit/>
+          </a:bodyPr>
+          <a:lstStyle/>
+          <a:p>
+            <a:pPr algn="l"/>
+            <a:r>
+              <a:rPr sz="1220" b="1">
+                <a:solidFill>
+                  <a:srgbClr val="123447"/>
+                </a:solidFill>
+                <a:latin typeface="Aptos"/>
+              </a:rPr>
+              <a:t>ANN/Keras test</a:t>
+            </a:r>
+          </a:p>
+        </p:txBody>
+      </p:sp>
+      <p:sp>
+        <p:nvSpPr>
+          <p:cNvPr id="19" name="TextBox 18"/>
+          <p:cNvSpPr txBox="1"/>
+          <p:nvPr/>
+        </p:nvSpPr>
+        <p:spPr>
+          <a:xfrm>
+            <a:off x="795528" y="4133087"/>
+            <a:ext cx="2295144" cy="475488"/>
+          </a:xfrm>
+          <a:prstGeom prst="rect">
+            <a:avLst/>
+          </a:prstGeom>
+          <a:noFill/>
+        </p:spPr>
+        <p:txBody>
+          <a:bodyPr wrap="none" lIns="45720" rIns="45720" anchor="t">
+            <a:spAutoFit/>
+          </a:bodyPr>
+          <a:lstStyle/>
+          <a:p>
+            <a:pPr algn="l"/>
+            <a:r>
+              <a:rPr sz="890" b="0">
+                <a:solidFill>
+                  <a:srgbClr val="1F2933"/>
+                </a:solidFill>
+                <a:latin typeface="Aptos"/>
+              </a:rPr>
+              <a:t>Best fit for nonlinear interactions among Rt, porosity, density, Vp, Vs, GR, and NMR-supported targets.</a:t>
+            </a:r>
+          </a:p>
+        </p:txBody>
+      </p:sp>
+      <p:sp>
+        <p:nvSpPr>
+          <p:cNvPr id="20" name="Rounded Rectangle 19"/>
+          <p:cNvSpPr/>
+          <p:nvPr/>
+        </p:nvSpPr>
+        <p:spPr>
+          <a:xfrm>
+            <a:off x="3429000" y="3749039"/>
+            <a:ext cx="2514600" cy="914400"/>
+          </a:xfrm>
+          <a:prstGeom prst="roundRect">
+            <a:avLst/>
+          </a:prstGeom>
+          <a:solidFill>
+            <a:srgbClr val="F4EFE6"/>
+          </a:solidFill>
+          <a:ln w="13970">
+            <a:solidFill>
+              <a:srgbClr val="167D8D"/>
+            </a:solidFill>
+          </a:ln>
+        </p:spPr>
+        <p:style>
+          <a:lnRef idx="1">
+            <a:schemeClr val="accent1"/>
+          </a:lnRef>
+          <a:fillRef idx="3">
+            <a:schemeClr val="accent1"/>
+          </a:fillRef>
+          <a:effectRef idx="2">
+            <a:schemeClr val="accent1"/>
+          </a:effectRef>
+          <a:fontRef idx="minor">
+            <a:schemeClr val="lt1"/>
+          </a:fontRef>
+        </p:style>
+        <p:txBody>
+          <a:bodyPr rtlCol="0" anchor="ctr"/>
+          <a:lstStyle/>
+          <a:p>
+            <a:pPr algn="ctr"/>
+          </a:p>
+        </p:txBody>
+      </p:sp>
+      <p:sp>
+        <p:nvSpPr>
+          <p:cNvPr id="21" name="TextBox 20"/>
+          <p:cNvSpPr txBox="1"/>
+          <p:nvPr/>
+        </p:nvSpPr>
+        <p:spPr>
+          <a:xfrm>
+            <a:off x="3538728" y="3840479"/>
+            <a:ext cx="2295144" cy="246888"/>
+          </a:xfrm>
+          <a:prstGeom prst="rect">
+            <a:avLst/>
+          </a:prstGeom>
+          <a:noFill/>
+        </p:spPr>
+        <p:txBody>
+          <a:bodyPr wrap="none" lIns="45720" rIns="45720" anchor="t">
+            <a:spAutoFit/>
+          </a:bodyPr>
+          <a:lstStyle/>
+          <a:p>
+            <a:pPr algn="l"/>
+            <a:r>
+              <a:rPr sz="1220" b="1">
+                <a:solidFill>
+                  <a:srgbClr val="123447"/>
+                </a:solidFill>
+                <a:latin typeface="Aptos"/>
+              </a:rPr>
+              <a:t>Guardrail</a:t>
+            </a:r>
+          </a:p>
+        </p:txBody>
+      </p:sp>
+      <p:sp>
+        <p:nvSpPr>
+          <p:cNvPr id="22" name="TextBox 21"/>
+          <p:cNvSpPr txBox="1"/>
+          <p:nvPr/>
+        </p:nvSpPr>
+        <p:spPr>
+          <a:xfrm>
+            <a:off x="3538728" y="4133087"/>
+            <a:ext cx="2295144" cy="475488"/>
+          </a:xfrm>
+          <a:prstGeom prst="rect">
+            <a:avLst/>
+          </a:prstGeom>
+          <a:noFill/>
+        </p:spPr>
+        <p:txBody>
+          <a:bodyPr wrap="none" lIns="45720" rIns="45720" anchor="t">
+            <a:spAutoFit/>
+          </a:bodyPr>
+          <a:lstStyle/>
+          <a:p>
+            <a:pPr algn="l"/>
+            <a:r>
+              <a:rPr sz="890" b="0">
+                <a:solidFill>
+                  <a:srgbClr val="1F2933"/>
+                </a:solidFill>
+                <a:latin typeface="Aptos"/>
+              </a:rPr>
+              <a:t>Do not train on Sgh, phase labels, rankings, or NMR-derived target columns as inputs.</a:t>
+            </a:r>
+          </a:p>
+        </p:txBody>
+      </p:sp>
+      <p:sp>
+        <p:nvSpPr>
+          <p:cNvPr id="23" name="Rounded Rectangle 22"/>
+          <p:cNvSpPr/>
+          <p:nvPr/>
+        </p:nvSpPr>
+        <p:spPr>
+          <a:xfrm>
+            <a:off x="6446520" y="3977639"/>
+            <a:ext cx="4846320" cy="914400"/>
+          </a:xfrm>
+          <a:prstGeom prst="roundRect">
+            <a:avLst/>
+          </a:prstGeom>
+          <a:solidFill>
+            <a:srgbClr val="EAF5F6"/>
+          </a:solidFill>
+          <a:ln w="13970">
+            <a:solidFill>
+              <a:srgbClr val="167D8D"/>
+            </a:solidFill>
+          </a:ln>
+        </p:spPr>
+        <p:style>
+          <a:lnRef idx="1">
+            <a:schemeClr val="accent1"/>
+          </a:lnRef>
+          <a:fillRef idx="3">
+            <a:schemeClr val="accent1"/>
+          </a:fillRef>
+          <a:effectRef idx="2">
+            <a:schemeClr val="accent1"/>
+          </a:effectRef>
+          <a:fontRef idx="minor">
+            <a:schemeClr val="lt1"/>
+          </a:fontRef>
+        </p:style>
+        <p:txBody>
+          <a:bodyPr rtlCol="0" anchor="ctr"/>
+          <a:lstStyle/>
+          <a:p>
+            <a:pPr algn="ctr"/>
+          </a:p>
+        </p:txBody>
+      </p:sp>
+      <p:sp>
+        <p:nvSpPr>
+          <p:cNvPr id="24" name="TextBox 23"/>
+          <p:cNvSpPr txBox="1"/>
+          <p:nvPr/>
+        </p:nvSpPr>
+        <p:spPr>
+          <a:xfrm>
+            <a:off x="6556248" y="4069079"/>
+            <a:ext cx="4626864" cy="246888"/>
+          </a:xfrm>
+          <a:prstGeom prst="rect">
+            <a:avLst/>
+          </a:prstGeom>
+          <a:noFill/>
+        </p:spPr>
+        <p:txBody>
+          <a:bodyPr wrap="none" lIns="45720" rIns="45720" anchor="t">
+            <a:spAutoFit/>
+          </a:bodyPr>
+          <a:lstStyle/>
+          <a:p>
+            <a:pPr algn="l"/>
+            <a:r>
+              <a:rPr sz="1220" b="1">
+                <a:solidFill>
+                  <a:srgbClr val="123447"/>
+                </a:solidFill>
+                <a:latin typeface="Aptos"/>
+              </a:rPr>
+              <a:t>Decision logic</a:t>
+            </a:r>
+          </a:p>
+        </p:txBody>
+      </p:sp>
+      <p:sp>
+        <p:nvSpPr>
+          <p:cNvPr id="25" name="TextBox 24"/>
+          <p:cNvSpPr txBox="1"/>
+          <p:nvPr/>
+        </p:nvSpPr>
+        <p:spPr>
+          <a:xfrm>
+            <a:off x="6556248" y="4361688"/>
+            <a:ext cx="4626864" cy="475488"/>
+          </a:xfrm>
+          <a:prstGeom prst="rect">
+            <a:avLst/>
+          </a:prstGeom>
+          <a:noFill/>
+        </p:spPr>
+        <p:txBody>
+          <a:bodyPr wrap="none" lIns="45720" rIns="45720" anchor="t">
+            <a:spAutoFit/>
+          </a:bodyPr>
+          <a:lstStyle/>
+          <a:p>
+            <a:pPr algn="l"/>
+            <a:r>
+              <a:rPr sz="890" b="0">
+                <a:solidFill>
+                  <a:srgbClr val="1F2933"/>
+                </a:solidFill>
+                <a:latin typeface="Aptos"/>
+              </a:rPr>
+              <a:t>Use the ANN only if it improves held-out-well performance beyond explainable baselines and stays geologically reasonable.</a:t>
+            </a:r>
+          </a:p>
+        </p:txBody>
+      </p:sp>
+      <p:sp>
+        <p:nvSpPr>
+          <p:cNvPr id="26" name="TextBox 25"/>
           <p:cNvSpPr txBox="1"/>
           <p:nvPr/>
         </p:nvSpPr>
@@ -7590,7 +8517,7 @@
                 </a:solidFill>
                 <a:latin typeface="Aptos"/>
               </a:rPr>
-              <a:t>Sources: USGS 2019; DOE/NETL; Chong et al. 2022; Lee and Collett 2011; Haines et al. 2022</a:t>
+              <a:t>Sources: Chong et al. 2022; USGS/NETL hydrate well-log studies; project target-leakage rules.</a:t>
             </a:r>
           </a:p>
         </p:txBody>
@@ -8244,14 +9171,14 @@
                 </a:solidFill>
                 <a:latin typeface="Aptos"/>
               </a:rPr>
-              <a:t>Regional context constrains interpretation but does not replace log evidence</a:t>
+              <a:t>Current Streamlit structural explorer view with a live-map link</a:t>
             </a:r>
           </a:p>
         </p:txBody>
       </p:sp>
       <p:pic>
         <p:nvPicPr>
-          <p:cNvPr id="4" name="Picture 3" descr="regional_3d_context.png"/>
+          <p:cNvPr id="4" name="Picture 3" descr="streamlit_3d_context_v2.png"/>
           <p:cNvPicPr>
             <a:picLocks noChangeAspect="1"/>
           </p:cNvPicPr>
@@ -8396,8 +9323,8 @@
         </p:nvSpPr>
         <p:spPr>
           <a:xfrm>
-            <a:off x="7726679" y="2788920"/>
-            <a:ext cx="3429000" cy="1097280"/>
+            <a:off x="7726679" y="2743200"/>
+            <a:ext cx="3429000" cy="960120"/>
           </a:xfrm>
           <a:prstGeom prst="roundRect">
             <a:avLst/>
@@ -8441,7 +9368,7 @@
         </p:nvSpPr>
         <p:spPr>
           <a:xfrm>
-            <a:off x="7836407" y="2880360"/>
+            <a:off x="7836407" y="2834640"/>
             <a:ext cx="3209544" cy="246888"/>
           </a:xfrm>
           <a:prstGeom prst="rect">
@@ -8463,7 +9390,7 @@
                 </a:solidFill>
                 <a:latin typeface="Aptos"/>
               </a:rPr>
-              <a:t>Boundary</a:t>
+              <a:t>Live interaction</a:t>
             </a:r>
           </a:p>
         </p:txBody>
@@ -8476,8 +9403,8 @@
         </p:nvSpPr>
         <p:spPr>
           <a:xfrm>
-            <a:off x="7836407" y="3172968"/>
-            <a:ext cx="3209544" cy="658368"/>
+            <a:off x="7836407" y="3127248"/>
+            <a:ext cx="3209544" cy="521208"/>
           </a:xfrm>
           <a:prstGeom prst="rect">
             <a:avLst/>
@@ -8498,21 +9425,56 @@
                 </a:solidFill>
                 <a:latin typeface="Aptos"/>
               </a:rPr>
-              <a:t>Public deck can show synthetic/public context; approved well identifiers and results stay in the authorized runtime.</a:t>
-            </a:r>
-          </a:p>
-        </p:txBody>
-      </p:sp>
-      <p:sp>
-        <p:nvSpPr>
-          <p:cNvPr id="11" name="Rounded Rectangle 10"/>
+              <a:t>Google Slides stores a static image; use the linked Streamlit app for rotation, zoom, and layer toggles.</a:t>
+            </a:r>
+          </a:p>
+        </p:txBody>
+      </p:sp>
+      <p:sp>
+        <p:nvSpPr>
+          <p:cNvPr id="11" name="TextBox 10"/>
+          <p:cNvSpPr txBox="1"/>
+          <p:nvPr/>
+        </p:nvSpPr>
+        <p:spPr>
+          <a:xfrm>
+            <a:off x="7818120" y="3840480"/>
+            <a:ext cx="3246120" cy="274320"/>
+          </a:xfrm>
+          <a:prstGeom prst="rect">
+            <a:avLst/>
+          </a:prstGeom>
+          <a:noFill/>
+        </p:spPr>
+        <p:txBody>
+          <a:bodyPr wrap="none" lIns="54864" rIns="54864">
+            <a:spAutoFit/>
+          </a:bodyPr>
+          <a:lstStyle/>
+          <a:p>
+            <a:r>
+              <a:rPr sz="1150" b="1">
+                <a:solidFill>
+                  <a:srgbClr val="167D8D"/>
+                </a:solidFill>
+                <a:latin typeface="Aptos"/>
+                <a:hlinkClick r:id="rId3"/>
+              </a:rPr>
+              <a:t>Open live Streamlit 3D explorer</a:t>
+            </a:r>
+          </a:p>
+        </p:txBody>
+      </p:sp>
+      <p:sp>
+        <p:nvSpPr>
+          <p:cNvPr id="12" name="Rounded Rectangle 11"/>
           <p:cNvSpPr/>
           <p:nvPr/>
         </p:nvSpPr>
         <p:spPr>
           <a:xfrm>
-            <a:off x="7726679" y="4343400"/>
-            <a:ext cx="3429000" cy="731520"/>
+            <a:off x="7726679" y="4407408"/>
+            <a:ext cx="3429000" cy="749808"/>
           </a:xfrm>
           <a:prstGeom prst="roundRect">
             <a:avLst/>
@@ -8550,13 +9512,13 @@
       </p:sp>
       <p:sp>
         <p:nvSpPr>
-          <p:cNvPr id="12" name="TextBox 11"/>
-          <p:cNvSpPr txBox="1"/>
-          <p:nvPr/>
-        </p:nvSpPr>
-        <p:spPr>
-          <a:xfrm>
-            <a:off x="7836407" y="4434840"/>
+          <p:cNvPr id="13" name="TextBox 12"/>
+          <p:cNvSpPr txBox="1"/>
+          <p:nvPr/>
+        </p:nvSpPr>
+        <p:spPr>
+          <a:xfrm>
+            <a:off x="7836407" y="4498848"/>
             <a:ext cx="3209544" cy="246888"/>
           </a:xfrm>
           <a:prstGeom prst="rect">
@@ -8578,21 +9540,21 @@
                 </a:solidFill>
                 <a:latin typeface="Aptos"/>
               </a:rPr>
-              <a:t>OpenScienceLab step</a:t>
-            </a:r>
-          </a:p>
-        </p:txBody>
-      </p:sp>
-      <p:sp>
-        <p:nvSpPr>
-          <p:cNvPr id="13" name="TextBox 12"/>
-          <p:cNvSpPr txBox="1"/>
-          <p:nvPr/>
-        </p:nvSpPr>
-        <p:spPr>
-          <a:xfrm>
-            <a:off x="7836407" y="4727448"/>
-            <a:ext cx="3209544" cy="292608"/>
+              <a:t>Data boundary</a:t>
+            </a:r>
+          </a:p>
+        </p:txBody>
+      </p:sp>
+      <p:sp>
+        <p:nvSpPr>
+          <p:cNvPr id="14" name="TextBox 13"/>
+          <p:cNvSpPr txBox="1"/>
+          <p:nvPr/>
+        </p:nvSpPr>
+        <p:spPr>
+          <a:xfrm>
+            <a:off x="7836407" y="4791456"/>
+            <a:ext cx="3209544" cy="310896"/>
           </a:xfrm>
           <a:prstGeom prst="rect">
             <a:avLst/>
@@ -8613,14 +9575,14 @@
                 </a:solidFill>
                 <a:latin typeface="Aptos"/>
               </a:rPr>
-              <a:t>Ready to replace this with approved-environment map output when you push/run there.</a:t>
-            </a:r>
-          </a:p>
-        </p:txBody>
-      </p:sp>
-      <p:sp>
-        <p:nvSpPr>
-          <p:cNvPr id="14" name="TextBox 13"/>
+              <a:t>Public map uses regional/public layers; approved well results stay runtime-only.</a:t>
+            </a:r>
+          </a:p>
+        </p:txBody>
+      </p:sp>
+      <p:sp>
+        <p:nvSpPr>
+          <p:cNvPr id="15" name="TextBox 14"/>
           <p:cNvSpPr txBox="1"/>
           <p:nvPr/>
         </p:nvSpPr>

</xml_diff>

<commit_message>
Add visual website redesign and refresh deliverables
</commit_message>
<xml_diff>
--- a/docs/project_blueprints/North_Slope_Gas_Hydrate_Reservoir_Characterization_Research_Overview.pptx
+++ b/docs/project_blueprints/North_Slope_Gas_Hydrate_Reservoir_Characterization_Research_Overview.pptx
@@ -3747,8 +3747,8 @@
         </p:nvSpPr>
         <p:spPr>
           <a:xfrm>
-            <a:off x="731520" y="1170432"/>
-            <a:ext cx="3154680" cy="1143000"/>
+            <a:off x="731520" y="1051560"/>
+            <a:ext cx="3154680" cy="960120"/>
           </a:xfrm>
           <a:prstGeom prst="roundRect">
             <a:avLst/>
@@ -3792,7 +3792,7 @@
         </p:nvSpPr>
         <p:spPr>
           <a:xfrm>
-            <a:off x="841248" y="1261872"/>
+            <a:off x="841248" y="1143000"/>
             <a:ext cx="2935224" cy="246888"/>
           </a:xfrm>
           <a:prstGeom prst="rect">
@@ -3827,8 +3827,8 @@
         </p:nvSpPr>
         <p:spPr>
           <a:xfrm>
-            <a:off x="841248" y="1554480"/>
-            <a:ext cx="2935224" cy="704088"/>
+            <a:off x="841248" y="1435607"/>
+            <a:ext cx="2935224" cy="521208"/>
           </a:xfrm>
           <a:prstGeom prst="rect">
             <a:avLst/>
@@ -3862,8 +3862,8 @@
         </p:nvSpPr>
         <p:spPr>
           <a:xfrm>
-            <a:off x="731520" y="2651760"/>
-            <a:ext cx="3154680" cy="1143000"/>
+            <a:off x="731520" y="2240280"/>
+            <a:ext cx="3154680" cy="960120"/>
           </a:xfrm>
           <a:prstGeom prst="roundRect">
             <a:avLst/>
@@ -3907,7 +3907,7 @@
         </p:nvSpPr>
         <p:spPr>
           <a:xfrm>
-            <a:off x="841248" y="2743200"/>
+            <a:off x="841248" y="2331720"/>
             <a:ext cx="2935224" cy="246888"/>
           </a:xfrm>
           <a:prstGeom prst="rect">
@@ -3942,8 +3942,8 @@
         </p:nvSpPr>
         <p:spPr>
           <a:xfrm>
-            <a:off x="841248" y="3035808"/>
-            <a:ext cx="2935224" cy="704088"/>
+            <a:off x="841248" y="2624328"/>
+            <a:ext cx="2935224" cy="521208"/>
           </a:xfrm>
           <a:prstGeom prst="rect">
             <a:avLst/>
@@ -3977,8 +3977,8 @@
         </p:nvSpPr>
         <p:spPr>
           <a:xfrm>
-            <a:off x="731520" y="4133087"/>
-            <a:ext cx="3154680" cy="1143000"/>
+            <a:off x="731520" y="3429000"/>
+            <a:ext cx="3154680" cy="960120"/>
           </a:xfrm>
           <a:prstGeom prst="roundRect">
             <a:avLst/>
@@ -4022,7 +4022,7 @@
         </p:nvSpPr>
         <p:spPr>
           <a:xfrm>
-            <a:off x="841248" y="4224527"/>
+            <a:off x="841248" y="3520440"/>
             <a:ext cx="2935224" cy="246888"/>
           </a:xfrm>
           <a:prstGeom prst="rect">
@@ -4057,8 +4057,8 @@
         </p:nvSpPr>
         <p:spPr>
           <a:xfrm>
-            <a:off x="841248" y="4517136"/>
-            <a:ext cx="2935224" cy="704088"/>
+            <a:off x="841248" y="3813048"/>
+            <a:ext cx="2935224" cy="521208"/>
           </a:xfrm>
           <a:prstGeom prst="rect">
             <a:avLst/>
@@ -4084,16 +4084,40 @@
           </a:p>
         </p:txBody>
       </p:sp>
-      <p:sp>
-        <p:nvSpPr>
-          <p:cNvPr id="13" name="Rounded Rectangle 12"/>
+      <p:pic>
+        <p:nvPicPr>
+          <p:cNvPr id="13" name="Picture 12" descr="subsurface_evidence_stack.png"/>
+          <p:cNvPicPr>
+            <a:picLocks noChangeAspect="1"/>
+          </p:cNvPicPr>
+          <p:nvPr/>
+        </p:nvPicPr>
+        <p:blipFill>
+          <a:blip r:embed="rId2"/>
+          <a:stretch>
+            <a:fillRect/>
+          </a:stretch>
+        </p:blipFill>
+        <p:spPr>
+          <a:xfrm>
+            <a:off x="4343400" y="1051560"/>
+            <a:ext cx="6629400" cy="3063240"/>
+          </a:xfrm>
+          <a:prstGeom prst="rect">
+            <a:avLst/>
+          </a:prstGeom>
+        </p:spPr>
+      </p:pic>
+      <p:sp>
+        <p:nvSpPr>
+          <p:cNvPr id="14" name="Rounded Rectangle 13"/>
           <p:cNvSpPr/>
           <p:nvPr/>
         </p:nvSpPr>
         <p:spPr>
           <a:xfrm>
-            <a:off x="4480560" y="1234440"/>
-            <a:ext cx="1225296" cy="621792"/>
+            <a:off x="4526280" y="4315968"/>
+            <a:ext cx="6263640" cy="822960"/>
           </a:xfrm>
           <a:prstGeom prst="roundRect">
             <a:avLst/>
@@ -4131,14 +4155,14 @@
       </p:sp>
       <p:sp>
         <p:nvSpPr>
-          <p:cNvPr id="14" name="TextBox 13"/>
-          <p:cNvSpPr txBox="1"/>
-          <p:nvPr/>
-        </p:nvSpPr>
-        <p:spPr>
-          <a:xfrm>
-            <a:off x="4590288" y="1325880"/>
-            <a:ext cx="1005840" cy="246888"/>
+          <p:cNvPr id="15" name="TextBox 14"/>
+          <p:cNvSpPr txBox="1"/>
+          <p:nvPr/>
+        </p:nvSpPr>
+        <p:spPr>
+          <a:xfrm>
+            <a:off x="4636008" y="4407407"/>
+            <a:ext cx="6044183" cy="246888"/>
           </a:xfrm>
           <a:prstGeom prst="rect">
             <a:avLst/>
@@ -4159,704 +4183,49 @@
                 </a:solidFill>
                 <a:latin typeface="Aptos"/>
               </a:rPr>
-              <a:t>stability</a:t>
-            </a:r>
-          </a:p>
-        </p:txBody>
-      </p:sp>
-      <p:cxnSp>
-        <p:nvCxnSpPr>
-          <p:cNvPr id="15" name="Connector 14"/>
-          <p:cNvCxnSpPr/>
-          <p:nvPr/>
-        </p:nvCxnSpPr>
-        <p:spPr>
-          <a:xfrm>
-            <a:off x="5724144" y="1545336"/>
-            <a:ext cx="256032" cy="0"/>
-          </a:xfrm>
-          <a:prstGeom prst="line">
-            <a:avLst/>
-          </a:prstGeom>
-          <a:ln w="25400">
-            <a:solidFill>
-              <a:srgbClr val="167D8D"/>
-            </a:solidFill>
-          </a:ln>
-        </p:spPr>
-        <p:style>
-          <a:lnRef idx="2">
-            <a:schemeClr val="accent1"/>
-          </a:lnRef>
-          <a:fillRef idx="0">
-            <a:schemeClr val="accent1"/>
-          </a:fillRef>
-          <a:effectRef idx="1">
-            <a:schemeClr val="accent1"/>
-          </a:effectRef>
-          <a:fontRef idx="minor">
-            <a:schemeClr val="tx1"/>
-          </a:fontRef>
-        </p:style>
-      </p:cxnSp>
-      <p:sp>
-        <p:nvSpPr>
-          <p:cNvPr id="16" name="Rounded Rectangle 15"/>
-          <p:cNvSpPr/>
-          <p:nvPr/>
-        </p:nvSpPr>
-        <p:spPr>
-          <a:xfrm>
-            <a:off x="6053328" y="1234440"/>
-            <a:ext cx="1225296" cy="621792"/>
-          </a:xfrm>
-          <a:prstGeom prst="roundRect">
-            <a:avLst/>
-          </a:prstGeom>
-          <a:solidFill>
-            <a:srgbClr val="EAF5F6"/>
-          </a:solidFill>
-          <a:ln w="13970">
-            <a:solidFill>
-              <a:srgbClr val="167D8D"/>
-            </a:solidFill>
-          </a:ln>
-        </p:spPr>
-        <p:style>
-          <a:lnRef idx="1">
-            <a:schemeClr val="accent1"/>
-          </a:lnRef>
-          <a:fillRef idx="3">
-            <a:schemeClr val="accent1"/>
-          </a:fillRef>
-          <a:effectRef idx="2">
-            <a:schemeClr val="accent1"/>
-          </a:effectRef>
-          <a:fontRef idx="minor">
-            <a:schemeClr val="lt1"/>
-          </a:fontRef>
-        </p:style>
-        <p:txBody>
-          <a:bodyPr rtlCol="0" anchor="ctr"/>
-          <a:lstStyle/>
-          <a:p>
-            <a:pPr algn="ctr"/>
+              <a:t>Core message</a:t>
+            </a:r>
+          </a:p>
+        </p:txBody>
+      </p:sp>
+      <p:sp>
+        <p:nvSpPr>
+          <p:cNvPr id="16" name="TextBox 15"/>
+          <p:cNvSpPr txBox="1"/>
+          <p:nvPr/>
+        </p:nvSpPr>
+        <p:spPr>
+          <a:xfrm>
+            <a:off x="4636008" y="4700016"/>
+            <a:ext cx="6044183" cy="384048"/>
+          </a:xfrm>
+          <a:prstGeom prst="rect">
+            <a:avLst/>
+          </a:prstGeom>
+          <a:noFill/>
+        </p:spPr>
+        <p:txBody>
+          <a:bodyPr wrap="none" lIns="45720" rIns="45720" anchor="t">
+            <a:spAutoFit/>
+          </a:bodyPr>
+          <a:lstStyle/>
+          <a:p>
+            <a:pPr algn="l"/>
+            <a:r>
+              <a:rPr sz="890" b="0">
+                <a:solidFill>
+                  <a:srgbClr val="1F2933"/>
+                </a:solidFill>
+                <a:latin typeface="Aptos"/>
+              </a:rPr>
+              <a:t>Stability and maps constrain confidence. Logs, NMR/core labels, and uncertainty determine interval decisions.</a:t>
+            </a:r>
           </a:p>
         </p:txBody>
       </p:sp>
       <p:sp>
         <p:nvSpPr>
           <p:cNvPr id="17" name="TextBox 16"/>
-          <p:cNvSpPr txBox="1"/>
-          <p:nvPr/>
-        </p:nvSpPr>
-        <p:spPr>
-          <a:xfrm>
-            <a:off x="6163056" y="1325880"/>
-            <a:ext cx="1005840" cy="246888"/>
-          </a:xfrm>
-          <a:prstGeom prst="rect">
-            <a:avLst/>
-          </a:prstGeom>
-          <a:noFill/>
-        </p:spPr>
-        <p:txBody>
-          <a:bodyPr wrap="none" lIns="45720" rIns="45720" anchor="t">
-            <a:spAutoFit/>
-          </a:bodyPr>
-          <a:lstStyle/>
-          <a:p>
-            <a:pPr algn="l"/>
-            <a:r>
-              <a:rPr sz="1220" b="1">
-                <a:solidFill>
-                  <a:srgbClr val="123447"/>
-                </a:solidFill>
-                <a:latin typeface="Aptos"/>
-              </a:rPr>
-              <a:t>reservoir</a:t>
-            </a:r>
-          </a:p>
-        </p:txBody>
-      </p:sp>
-      <p:cxnSp>
-        <p:nvCxnSpPr>
-          <p:cNvPr id="18" name="Connector 17"/>
-          <p:cNvCxnSpPr/>
-          <p:nvPr/>
-        </p:nvCxnSpPr>
-        <p:spPr>
-          <a:xfrm>
-            <a:off x="7296912" y="1545336"/>
-            <a:ext cx="256032" cy="0"/>
-          </a:xfrm>
-          <a:prstGeom prst="line">
-            <a:avLst/>
-          </a:prstGeom>
-          <a:ln w="25400">
-            <a:solidFill>
-              <a:srgbClr val="167D8D"/>
-            </a:solidFill>
-          </a:ln>
-        </p:spPr>
-        <p:style>
-          <a:lnRef idx="2">
-            <a:schemeClr val="accent1"/>
-          </a:lnRef>
-          <a:fillRef idx="0">
-            <a:schemeClr val="accent1"/>
-          </a:fillRef>
-          <a:effectRef idx="1">
-            <a:schemeClr val="accent1"/>
-          </a:effectRef>
-          <a:fontRef idx="minor">
-            <a:schemeClr val="tx1"/>
-          </a:fontRef>
-        </p:style>
-      </p:cxnSp>
-      <p:sp>
-        <p:nvSpPr>
-          <p:cNvPr id="19" name="Rounded Rectangle 18"/>
-          <p:cNvSpPr/>
-          <p:nvPr/>
-        </p:nvSpPr>
-        <p:spPr>
-          <a:xfrm>
-            <a:off x="7626096" y="1234440"/>
-            <a:ext cx="1225296" cy="621792"/>
-          </a:xfrm>
-          <a:prstGeom prst="roundRect">
-            <a:avLst/>
-          </a:prstGeom>
-          <a:solidFill>
-            <a:srgbClr val="EAF5F6"/>
-          </a:solidFill>
-          <a:ln w="13970">
-            <a:solidFill>
-              <a:srgbClr val="167D8D"/>
-            </a:solidFill>
-          </a:ln>
-        </p:spPr>
-        <p:style>
-          <a:lnRef idx="1">
-            <a:schemeClr val="accent1"/>
-          </a:lnRef>
-          <a:fillRef idx="3">
-            <a:schemeClr val="accent1"/>
-          </a:fillRef>
-          <a:effectRef idx="2">
-            <a:schemeClr val="accent1"/>
-          </a:effectRef>
-          <a:fontRef idx="minor">
-            <a:schemeClr val="lt1"/>
-          </a:fontRef>
-        </p:style>
-        <p:txBody>
-          <a:bodyPr rtlCol="0" anchor="ctr"/>
-          <a:lstStyle/>
-          <a:p>
-            <a:pPr algn="ctr"/>
-          </a:p>
-        </p:txBody>
-      </p:sp>
-      <p:sp>
-        <p:nvSpPr>
-          <p:cNvPr id="20" name="TextBox 19"/>
-          <p:cNvSpPr txBox="1"/>
-          <p:nvPr/>
-        </p:nvSpPr>
-        <p:spPr>
-          <a:xfrm>
-            <a:off x="7735823" y="1325880"/>
-            <a:ext cx="1005840" cy="246888"/>
-          </a:xfrm>
-          <a:prstGeom prst="rect">
-            <a:avLst/>
-          </a:prstGeom>
-          <a:noFill/>
-        </p:spPr>
-        <p:txBody>
-          <a:bodyPr wrap="none" lIns="45720" rIns="45720" anchor="t">
-            <a:spAutoFit/>
-          </a:bodyPr>
-          <a:lstStyle/>
-          <a:p>
-            <a:pPr algn="l"/>
-            <a:r>
-              <a:rPr sz="1220" b="1">
-                <a:solidFill>
-                  <a:srgbClr val="123447"/>
-                </a:solidFill>
-                <a:latin typeface="Aptos"/>
-              </a:rPr>
-              <a:t>gas charge</a:t>
-            </a:r>
-          </a:p>
-        </p:txBody>
-      </p:sp>
-      <p:cxnSp>
-        <p:nvCxnSpPr>
-          <p:cNvPr id="21" name="Connector 20"/>
-          <p:cNvCxnSpPr/>
-          <p:nvPr/>
-        </p:nvCxnSpPr>
-        <p:spPr>
-          <a:xfrm>
-            <a:off x="8869680" y="1545336"/>
-            <a:ext cx="256032" cy="0"/>
-          </a:xfrm>
-          <a:prstGeom prst="line">
-            <a:avLst/>
-          </a:prstGeom>
-          <a:ln w="25400">
-            <a:solidFill>
-              <a:srgbClr val="167D8D"/>
-            </a:solidFill>
-          </a:ln>
-        </p:spPr>
-        <p:style>
-          <a:lnRef idx="2">
-            <a:schemeClr val="accent1"/>
-          </a:lnRef>
-          <a:fillRef idx="0">
-            <a:schemeClr val="accent1"/>
-          </a:fillRef>
-          <a:effectRef idx="1">
-            <a:schemeClr val="accent1"/>
-          </a:effectRef>
-          <a:fontRef idx="minor">
-            <a:schemeClr val="tx1"/>
-          </a:fontRef>
-        </p:style>
-      </p:cxnSp>
-      <p:sp>
-        <p:nvSpPr>
-          <p:cNvPr id="22" name="Rounded Rectangle 21"/>
-          <p:cNvSpPr/>
-          <p:nvPr/>
-        </p:nvSpPr>
-        <p:spPr>
-          <a:xfrm>
-            <a:off x="9198864" y="1234440"/>
-            <a:ext cx="1225296" cy="621792"/>
-          </a:xfrm>
-          <a:prstGeom prst="roundRect">
-            <a:avLst/>
-          </a:prstGeom>
-          <a:solidFill>
-            <a:srgbClr val="EAF5F6"/>
-          </a:solidFill>
-          <a:ln w="13970">
-            <a:solidFill>
-              <a:srgbClr val="167D8D"/>
-            </a:solidFill>
-          </a:ln>
-        </p:spPr>
-        <p:style>
-          <a:lnRef idx="1">
-            <a:schemeClr val="accent1"/>
-          </a:lnRef>
-          <a:fillRef idx="3">
-            <a:schemeClr val="accent1"/>
-          </a:fillRef>
-          <a:effectRef idx="2">
-            <a:schemeClr val="accent1"/>
-          </a:effectRef>
-          <a:fontRef idx="minor">
-            <a:schemeClr val="lt1"/>
-          </a:fontRef>
-        </p:style>
-        <p:txBody>
-          <a:bodyPr rtlCol="0" anchor="ctr"/>
-          <a:lstStyle/>
-          <a:p>
-            <a:pPr algn="ctr"/>
-          </a:p>
-        </p:txBody>
-      </p:sp>
-      <p:sp>
-        <p:nvSpPr>
-          <p:cNvPr id="23" name="TextBox 22"/>
-          <p:cNvSpPr txBox="1"/>
-          <p:nvPr/>
-        </p:nvSpPr>
-        <p:spPr>
-          <a:xfrm>
-            <a:off x="9308592" y="1325880"/>
-            <a:ext cx="1005840" cy="246888"/>
-          </a:xfrm>
-          <a:prstGeom prst="rect">
-            <a:avLst/>
-          </a:prstGeom>
-          <a:noFill/>
-        </p:spPr>
-        <p:txBody>
-          <a:bodyPr wrap="none" lIns="45720" rIns="45720" anchor="t">
-            <a:spAutoFit/>
-          </a:bodyPr>
-          <a:lstStyle/>
-          <a:p>
-            <a:pPr algn="l"/>
-            <a:r>
-              <a:rPr sz="1220" b="1">
-                <a:solidFill>
-                  <a:srgbClr val="123447"/>
-                </a:solidFill>
-                <a:latin typeface="Aptos"/>
-              </a:rPr>
-              <a:t>logs/core</a:t>
-            </a:r>
-          </a:p>
-        </p:txBody>
-      </p:sp>
-      <p:cxnSp>
-        <p:nvCxnSpPr>
-          <p:cNvPr id="24" name="Connector 23"/>
-          <p:cNvCxnSpPr/>
-          <p:nvPr/>
-        </p:nvCxnSpPr>
-        <p:spPr>
-          <a:xfrm>
-            <a:off x="10442448" y="1545336"/>
-            <a:ext cx="256032" cy="0"/>
-          </a:xfrm>
-          <a:prstGeom prst="line">
-            <a:avLst/>
-          </a:prstGeom>
-          <a:ln w="25400">
-            <a:solidFill>
-              <a:srgbClr val="167D8D"/>
-            </a:solidFill>
-          </a:ln>
-        </p:spPr>
-        <p:style>
-          <a:lnRef idx="2">
-            <a:schemeClr val="accent1"/>
-          </a:lnRef>
-          <a:fillRef idx="0">
-            <a:schemeClr val="accent1"/>
-          </a:fillRef>
-          <a:effectRef idx="1">
-            <a:schemeClr val="accent1"/>
-          </a:effectRef>
-          <a:fontRef idx="minor">
-            <a:schemeClr val="tx1"/>
-          </a:fontRef>
-        </p:style>
-      </p:cxnSp>
-      <p:sp>
-        <p:nvSpPr>
-          <p:cNvPr id="25" name="Rounded Rectangle 24"/>
-          <p:cNvSpPr/>
-          <p:nvPr/>
-        </p:nvSpPr>
-        <p:spPr>
-          <a:xfrm>
-            <a:off x="10771632" y="1234440"/>
-            <a:ext cx="1225296" cy="621792"/>
-          </a:xfrm>
-          <a:prstGeom prst="roundRect">
-            <a:avLst/>
-          </a:prstGeom>
-          <a:solidFill>
-            <a:srgbClr val="F4EFE6"/>
-          </a:solidFill>
-          <a:ln w="13970">
-            <a:solidFill>
-              <a:srgbClr val="167D8D"/>
-            </a:solidFill>
-          </a:ln>
-        </p:spPr>
-        <p:style>
-          <a:lnRef idx="1">
-            <a:schemeClr val="accent1"/>
-          </a:lnRef>
-          <a:fillRef idx="3">
-            <a:schemeClr val="accent1"/>
-          </a:fillRef>
-          <a:effectRef idx="2">
-            <a:schemeClr val="accent1"/>
-          </a:effectRef>
-          <a:fontRef idx="minor">
-            <a:schemeClr val="lt1"/>
-          </a:fontRef>
-        </p:style>
-        <p:txBody>
-          <a:bodyPr rtlCol="0" anchor="ctr"/>
-          <a:lstStyle/>
-          <a:p>
-            <a:pPr algn="ctr"/>
-          </a:p>
-        </p:txBody>
-      </p:sp>
-      <p:sp>
-        <p:nvSpPr>
-          <p:cNvPr id="26" name="TextBox 25"/>
-          <p:cNvSpPr txBox="1"/>
-          <p:nvPr/>
-        </p:nvSpPr>
-        <p:spPr>
-          <a:xfrm>
-            <a:off x="10881360" y="1325880"/>
-            <a:ext cx="1005840" cy="246888"/>
-          </a:xfrm>
-          <a:prstGeom prst="rect">
-            <a:avLst/>
-          </a:prstGeom>
-          <a:noFill/>
-        </p:spPr>
-        <p:txBody>
-          <a:bodyPr wrap="none" lIns="45720" rIns="45720" anchor="t">
-            <a:spAutoFit/>
-          </a:bodyPr>
-          <a:lstStyle/>
-          <a:p>
-            <a:pPr algn="l"/>
-            <a:r>
-              <a:rPr sz="1220" b="1">
-                <a:solidFill>
-                  <a:srgbClr val="123447"/>
-                </a:solidFill>
-                <a:latin typeface="Aptos"/>
-              </a:rPr>
-              <a:t>saturation</a:t>
-            </a:r>
-          </a:p>
-        </p:txBody>
-      </p:sp>
-      <p:sp>
-        <p:nvSpPr>
-          <p:cNvPr id="27" name="Rounded Rectangle 26"/>
-          <p:cNvSpPr/>
-          <p:nvPr/>
-        </p:nvSpPr>
-        <p:spPr>
-          <a:xfrm>
-            <a:off x="4480560" y="2788920"/>
-            <a:ext cx="6263640" cy="1280160"/>
-          </a:xfrm>
-          <a:prstGeom prst="roundRect">
-            <a:avLst/>
-          </a:prstGeom>
-          <a:solidFill>
-            <a:srgbClr val="EAF5F6"/>
-          </a:solidFill>
-          <a:ln w="13970">
-            <a:solidFill>
-              <a:srgbClr val="167D8D"/>
-            </a:solidFill>
-          </a:ln>
-        </p:spPr>
-        <p:style>
-          <a:lnRef idx="1">
-            <a:schemeClr val="accent1"/>
-          </a:lnRef>
-          <a:fillRef idx="3">
-            <a:schemeClr val="accent1"/>
-          </a:fillRef>
-          <a:effectRef idx="2">
-            <a:schemeClr val="accent1"/>
-          </a:effectRef>
-          <a:fontRef idx="minor">
-            <a:schemeClr val="lt1"/>
-          </a:fontRef>
-        </p:style>
-        <p:txBody>
-          <a:bodyPr rtlCol="0" anchor="ctr"/>
-          <a:lstStyle/>
-          <a:p>
-            <a:pPr algn="ctr"/>
-          </a:p>
-        </p:txBody>
-      </p:sp>
-      <p:sp>
-        <p:nvSpPr>
-          <p:cNvPr id="28" name="TextBox 27"/>
-          <p:cNvSpPr txBox="1"/>
-          <p:nvPr/>
-        </p:nvSpPr>
-        <p:spPr>
-          <a:xfrm>
-            <a:off x="4590288" y="2880360"/>
-            <a:ext cx="6044183" cy="246888"/>
-          </a:xfrm>
-          <a:prstGeom prst="rect">
-            <a:avLst/>
-          </a:prstGeom>
-          <a:noFill/>
-        </p:spPr>
-        <p:txBody>
-          <a:bodyPr wrap="none" lIns="45720" rIns="45720" anchor="t">
-            <a:spAutoFit/>
-          </a:bodyPr>
-          <a:lstStyle/>
-          <a:p>
-            <a:pPr algn="l"/>
-            <a:r>
-              <a:rPr sz="1220" b="1">
-                <a:solidFill>
-                  <a:srgbClr val="123447"/>
-                </a:solidFill>
-                <a:latin typeface="Aptos"/>
-              </a:rPr>
-              <a:t>Core message</a:t>
-            </a:r>
-          </a:p>
-        </p:txBody>
-      </p:sp>
-      <p:sp>
-        <p:nvSpPr>
-          <p:cNvPr id="29" name="TextBox 28"/>
-          <p:cNvSpPr txBox="1"/>
-          <p:nvPr/>
-        </p:nvSpPr>
-        <p:spPr>
-          <a:xfrm>
-            <a:off x="4590288" y="3172968"/>
-            <a:ext cx="6044183" cy="841247"/>
-          </a:xfrm>
-          <a:prstGeom prst="rect">
-            <a:avLst/>
-          </a:prstGeom>
-          <a:noFill/>
-        </p:spPr>
-        <p:txBody>
-          <a:bodyPr wrap="none" lIns="45720" rIns="45720" anchor="t">
-            <a:spAutoFit/>
-          </a:bodyPr>
-          <a:lstStyle/>
-          <a:p>
-            <a:pPr algn="l"/>
-            <a:r>
-              <a:rPr sz="890" b="0">
-                <a:solidFill>
-                  <a:srgbClr val="1F2933"/>
-                </a:solidFill>
-                <a:latin typeface="Aptos"/>
-              </a:rPr>
-              <a:t>Stability is necessary but not proof. The project asks whether well logs, NMR, and core evidence jointly support hydrate occurrence and saturation.</a:t>
-            </a:r>
-          </a:p>
-        </p:txBody>
-      </p:sp>
-      <p:sp>
-        <p:nvSpPr>
-          <p:cNvPr id="30" name="Rounded Rectangle 29"/>
-          <p:cNvSpPr/>
-          <p:nvPr/>
-        </p:nvSpPr>
-        <p:spPr>
-          <a:xfrm>
-            <a:off x="4480560" y="4498848"/>
-            <a:ext cx="6263640" cy="822960"/>
-          </a:xfrm>
-          <a:prstGeom prst="roundRect">
-            <a:avLst/>
-          </a:prstGeom>
-          <a:solidFill>
-            <a:srgbClr val="F4EFE6"/>
-          </a:solidFill>
-          <a:ln w="13970">
-            <a:solidFill>
-              <a:srgbClr val="167D8D"/>
-            </a:solidFill>
-          </a:ln>
-        </p:spPr>
-        <p:style>
-          <a:lnRef idx="1">
-            <a:schemeClr val="accent1"/>
-          </a:lnRef>
-          <a:fillRef idx="3">
-            <a:schemeClr val="accent1"/>
-          </a:fillRef>
-          <a:effectRef idx="2">
-            <a:schemeClr val="accent1"/>
-          </a:effectRef>
-          <a:fontRef idx="minor">
-            <a:schemeClr val="lt1"/>
-          </a:fontRef>
-        </p:style>
-        <p:txBody>
-          <a:bodyPr rtlCol="0" anchor="ctr"/>
-          <a:lstStyle/>
-          <a:p>
-            <a:pPr algn="ctr"/>
-          </a:p>
-        </p:txBody>
-      </p:sp>
-      <p:sp>
-        <p:nvSpPr>
-          <p:cNvPr id="31" name="TextBox 30"/>
-          <p:cNvSpPr txBox="1"/>
-          <p:nvPr/>
-        </p:nvSpPr>
-        <p:spPr>
-          <a:xfrm>
-            <a:off x="4590288" y="4590288"/>
-            <a:ext cx="6044183" cy="246888"/>
-          </a:xfrm>
-          <a:prstGeom prst="rect">
-            <a:avLst/>
-          </a:prstGeom>
-          <a:noFill/>
-        </p:spPr>
-        <p:txBody>
-          <a:bodyPr wrap="none" lIns="45720" rIns="45720" anchor="t">
-            <a:spAutoFit/>
-          </a:bodyPr>
-          <a:lstStyle/>
-          <a:p>
-            <a:pPr algn="l"/>
-            <a:r>
-              <a:rPr sz="1220" b="1">
-                <a:solidFill>
-                  <a:srgbClr val="123447"/>
-                </a:solidFill>
-                <a:latin typeface="Aptos"/>
-              </a:rPr>
-              <a:t>Energy-security framing</a:t>
-            </a:r>
-          </a:p>
-        </p:txBody>
-      </p:sp>
-      <p:sp>
-        <p:nvSpPr>
-          <p:cNvPr id="32" name="TextBox 31"/>
-          <p:cNvSpPr txBox="1"/>
-          <p:nvPr/>
-        </p:nvSpPr>
-        <p:spPr>
-          <a:xfrm>
-            <a:off x="4590288" y="4882896"/>
-            <a:ext cx="6044183" cy="384048"/>
-          </a:xfrm>
-          <a:prstGeom prst="rect">
-            <a:avLst/>
-          </a:prstGeom>
-          <a:noFill/>
-        </p:spPr>
-        <p:txBody>
-          <a:bodyPr wrap="none" lIns="45720" rIns="45720" anchor="t">
-            <a:spAutoFit/>
-          </a:bodyPr>
-          <a:lstStyle/>
-          <a:p>
-            <a:pPr algn="l"/>
-            <a:r>
-              <a:rPr sz="890" b="0">
-                <a:solidFill>
-                  <a:srgbClr val="1F2933"/>
-                </a:solidFill>
-                <a:latin typeface="Aptos"/>
-              </a:rPr>
-              <a:t>The presentation stays focused on natural-gas resource characterization, not environmental-impact discussion.</a:t>
-            </a:r>
-          </a:p>
-        </p:txBody>
-      </p:sp>
-      <p:sp>
-        <p:nvSpPr>
-          <p:cNvPr id="33" name="TextBox 32"/>
           <p:cNvSpPr txBox="1"/>
           <p:nvPr/>
         </p:nvSpPr>
@@ -4937,7 +4306,7 @@
                 </a:solidFill>
                 <a:latin typeface="Aptos"/>
               </a:rPr>
-              <a:t>Parameters: Well-Log Scaffold</a:t>
+              <a:t>Parameters: Header-Derived Well-Log Scaffold</a:t>
             </a:r>
           </a:p>
         </p:txBody>
@@ -4972,7 +4341,7 @@
                 </a:solidFill>
                 <a:latin typeface="Aptos"/>
               </a:rPr>
-              <a:t>Measured curves, derived physics, QC fields, and targets stay separated</a:t>
+              <a:t>Only Excel header/schema references are available; generated rows are synthetic</a:t>
             </a:r>
           </a:p>
         </p:txBody>
@@ -5766,7 +5135,7 @@
                 </a:solidFill>
                 <a:latin typeface="Aptos"/>
               </a:rPr>
-              <a:t>Embedded website scaffold</a:t>
+              <a:t>Data provenance</a:t>
             </a:r>
           </a:p>
         </p:txBody>
@@ -5801,7 +5170,7 @@
                 </a:solidFill>
                 <a:latin typeface="Aptos"/>
               </a:rPr>
-              <a:t>Synthetic well-log panel with interpretation callouts from the Future Well-Log Engine.</a:t>
+              <a:t>Header-derived synthetic records only. Values test layout and QA; they are not user-supplied sample data.</a:t>
             </a:r>
           </a:p>
         </p:txBody>
@@ -5836,7 +5205,7 @@
                 </a:solidFill>
                 <a:latin typeface="Aptos"/>
               </a:rPr>
-              <a:t>Sources: recovered header screenshots; project Q&amp;A update; Lee and Collett 2011; Haines et al. 2022</a:t>
+              <a:t>Sources: three Excel header references; project Q&amp;A update; Lee and Collett 2011; Haines et al. 2022</a:t>
             </a:r>
           </a:p>
         </p:txBody>
@@ -7618,7 +6987,7 @@
                 </a:solidFill>
                 <a:latin typeface="Aptos"/>
               </a:rPr>
-              <a:t>ML Methodology: Why This Architecture Fits Well Logs</a:t>
+              <a:t>Website Integration: Four-Page Visual Workflow</a:t>
             </a:r>
           </a:p>
         </p:txBody>
@@ -7653,14 +7022,14 @@
                 </a:solidFill>
                 <a:latin typeface="Aptos"/>
               </a:rPr>
-              <a:t>Depth-indexed curves need both explainable baselines and nonlinear models</a:t>
+              <a:t>Streamlit is a public-source prototype and figure-generation surface</a:t>
             </a:r>
           </a:p>
         </p:txBody>
       </p:sp>
       <p:pic>
         <p:nvPicPr>
-          <p:cNvPr id="4" name="Picture 3" descr="sweet_spot_ranking.png"/>
+          <p:cNvPr id="4" name="Picture 3" descr="website_four_page_flow.png"/>
           <p:cNvPicPr>
             <a:picLocks noChangeAspect="1"/>
           </p:cNvPicPr>
@@ -7674,8 +7043,8 @@
         </p:blipFill>
         <p:spPr>
           <a:xfrm>
-            <a:off x="6400800" y="1078992"/>
-            <a:ext cx="4892040" cy="2423160"/>
+            <a:off x="868680" y="1024128"/>
+            <a:ext cx="10287000" cy="2971800"/>
           </a:xfrm>
           <a:prstGeom prst="rect">
             <a:avLst/>
@@ -7690,8 +7059,8 @@
         </p:nvSpPr>
         <p:spPr>
           <a:xfrm>
-            <a:off x="685800" y="1143000"/>
-            <a:ext cx="2514600" cy="914400"/>
+            <a:off x="868680" y="4407408"/>
+            <a:ext cx="3154680" cy="868680"/>
           </a:xfrm>
           <a:prstGeom prst="roundRect">
             <a:avLst/>
@@ -7735,8 +7104,8 @@
         </p:nvSpPr>
         <p:spPr>
           <a:xfrm>
-            <a:off x="795528" y="1234440"/>
-            <a:ext cx="2295144" cy="246888"/>
+            <a:off x="978407" y="4498848"/>
+            <a:ext cx="2935224" cy="246888"/>
           </a:xfrm>
           <a:prstGeom prst="rect">
             <a:avLst/>
@@ -7757,7 +7126,7 @@
                 </a:solidFill>
                 <a:latin typeface="Aptos"/>
               </a:rPr>
-              <a:t>Classification branch</a:t>
+              <a:t>Overview</a:t>
             </a:r>
           </a:p>
         </p:txBody>
@@ -7770,8 +7139,8 @@
         </p:nvSpPr>
         <p:spPr>
           <a:xfrm>
-            <a:off x="795528" y="1527048"/>
-            <a:ext cx="2295144" cy="475488"/>
+            <a:off x="978407" y="4791456"/>
+            <a:ext cx="2935224" cy="429768"/>
           </a:xfrm>
           <a:prstGeom prst="rect">
             <a:avLst/>
@@ -7792,7 +7161,7 @@
                 </a:solidFill>
                 <a:latin typeface="Aptos"/>
               </a:rPr>
-              <a:t>Detect hydrate-supportive intervals or phase classes from multi-log agreement, lithology, and QC context.</a:t>
+              <a:t>Project goal, data-to-decision pipeline, and evidence stack.</a:t>
             </a:r>
           </a:p>
         </p:txBody>
@@ -7805,8 +7174,8 @@
         </p:nvSpPr>
         <p:spPr>
           <a:xfrm>
-            <a:off x="3429000" y="1143000"/>
-            <a:ext cx="2514600" cy="914400"/>
+            <a:off x="4315968" y="4407408"/>
+            <a:ext cx="3154680" cy="868680"/>
           </a:xfrm>
           <a:prstGeom prst="roundRect">
             <a:avLst/>
@@ -7850,8 +7219,8 @@
         </p:nvSpPr>
         <p:spPr>
           <a:xfrm>
-            <a:off x="3538728" y="1234440"/>
-            <a:ext cx="2295144" cy="246888"/>
+            <a:off x="4425696" y="4498848"/>
+            <a:ext cx="2935224" cy="246888"/>
           </a:xfrm>
           <a:prstGeom prst="rect">
             <a:avLst/>
@@ -7872,7 +7241,7 @@
                 </a:solidFill>
                 <a:latin typeface="Aptos"/>
               </a:rPr>
-              <a:t>Regression branch</a:t>
+              <a:t>Analyze Hydrates</a:t>
             </a:r>
           </a:p>
         </p:txBody>
@@ -7885,8 +7254,8 @@
         </p:nvSpPr>
         <p:spPr>
           <a:xfrm>
-            <a:off x="3538728" y="1527048"/>
-            <a:ext cx="2295144" cy="475488"/>
+            <a:off x="4425696" y="4791456"/>
+            <a:ext cx="2935224" cy="429768"/>
           </a:xfrm>
           <a:prstGeom prst="rect">
             <a:avLst/>
@@ -7907,7 +7276,7 @@
                 </a:solidFill>
                 <a:latin typeface="Aptos"/>
               </a:rPr>
-              <a:t>Estimate continuous hydrate saturation only from allowed predictors and calibrated targets.</a:t>
+              <a:t>Header-derived synthetic log board, target guardrail, runtime readiness.</a:t>
             </a:r>
           </a:p>
         </p:txBody>
@@ -7920,8 +7289,8 @@
         </p:nvSpPr>
         <p:spPr>
           <a:xfrm>
-            <a:off x="685800" y="2450592"/>
-            <a:ext cx="2514600" cy="914400"/>
+            <a:off x="7754112" y="4407408"/>
+            <a:ext cx="3154680" cy="868680"/>
           </a:xfrm>
           <a:prstGeom prst="roundRect">
             <a:avLst/>
@@ -7965,8 +7334,8 @@
         </p:nvSpPr>
         <p:spPr>
           <a:xfrm>
-            <a:off x="795528" y="2542032"/>
-            <a:ext cx="2295144" cy="246888"/>
+            <a:off x="7863840" y="4498848"/>
+            <a:ext cx="2935224" cy="246888"/>
           </a:xfrm>
           <a:prstGeom prst="rect">
             <a:avLst/>
@@ -7987,7 +7356,7 @@
                 </a:solidFill>
                 <a:latin typeface="Aptos"/>
               </a:rPr>
-              <a:t>Linear baseline</a:t>
+              <a:t>Project Plan</a:t>
             </a:r>
           </a:p>
         </p:txBody>
@@ -8000,8 +7369,8 @@
         </p:nvSpPr>
         <p:spPr>
           <a:xfrm>
-            <a:off x="795528" y="2834640"/>
-            <a:ext cx="2295144" cy="475488"/>
+            <a:off x="7863840" y="4791456"/>
+            <a:ext cx="2935224" cy="429768"/>
           </a:xfrm>
           <a:prstGeom prst="rect">
             <a:avLst/>
@@ -8022,474 +7391,14 @@
                 </a:solidFill>
                 <a:latin typeface="Aptos"/>
               </a:rPr>
-              <a:t>Shows defensible directionality and exposes whether a simple relation is already sufficient.</a:t>
-            </a:r>
-          </a:p>
-        </p:txBody>
-      </p:sp>
-      <p:sp>
-        <p:nvSpPr>
-          <p:cNvPr id="14" name="Rounded Rectangle 13"/>
-          <p:cNvSpPr/>
-          <p:nvPr/>
-        </p:nvSpPr>
-        <p:spPr>
-          <a:xfrm>
-            <a:off x="3429000" y="2450592"/>
-            <a:ext cx="2514600" cy="914400"/>
-          </a:xfrm>
-          <a:prstGeom prst="roundRect">
-            <a:avLst/>
-          </a:prstGeom>
-          <a:solidFill>
-            <a:srgbClr val="EAF5F6"/>
-          </a:solidFill>
-          <a:ln w="13970">
-            <a:solidFill>
-              <a:srgbClr val="167D8D"/>
-            </a:solidFill>
-          </a:ln>
-        </p:spPr>
-        <p:style>
-          <a:lnRef idx="1">
-            <a:schemeClr val="accent1"/>
-          </a:lnRef>
-          <a:fillRef idx="3">
-            <a:schemeClr val="accent1"/>
-          </a:fillRef>
-          <a:effectRef idx="2">
-            <a:schemeClr val="accent1"/>
-          </a:effectRef>
-          <a:fontRef idx="minor">
-            <a:schemeClr val="lt1"/>
-          </a:fontRef>
-        </p:style>
-        <p:txBody>
-          <a:bodyPr rtlCol="0" anchor="ctr"/>
-          <a:lstStyle/>
-          <a:p>
-            <a:pPr algn="ctr"/>
-          </a:p>
-        </p:txBody>
-      </p:sp>
-      <p:sp>
-        <p:nvSpPr>
-          <p:cNvPr id="15" name="TextBox 14"/>
-          <p:cNvSpPr txBox="1"/>
-          <p:nvPr/>
-        </p:nvSpPr>
-        <p:spPr>
-          <a:xfrm>
-            <a:off x="3538728" y="2542032"/>
-            <a:ext cx="2295144" cy="246888"/>
-          </a:xfrm>
-          <a:prstGeom prst="rect">
-            <a:avLst/>
-          </a:prstGeom>
-          <a:noFill/>
-        </p:spPr>
-        <p:txBody>
-          <a:bodyPr wrap="none" lIns="45720" rIns="45720" anchor="t">
-            <a:spAutoFit/>
-          </a:bodyPr>
-          <a:lstStyle/>
-          <a:p>
-            <a:pPr algn="l"/>
-            <a:r>
-              <a:rPr sz="1220" b="1">
-                <a:solidFill>
-                  <a:srgbClr val="123447"/>
-                </a:solidFill>
-                <a:latin typeface="Aptos"/>
-              </a:rPr>
-              <a:t>Tree/GBM test</a:t>
-            </a:r>
-          </a:p>
-        </p:txBody>
-      </p:sp>
-      <p:sp>
-        <p:nvSpPr>
-          <p:cNvPr id="16" name="TextBox 15"/>
-          <p:cNvSpPr txBox="1"/>
-          <p:nvPr/>
-        </p:nvSpPr>
-        <p:spPr>
-          <a:xfrm>
-            <a:off x="3538728" y="2834640"/>
-            <a:ext cx="2295144" cy="475488"/>
-          </a:xfrm>
-          <a:prstGeom prst="rect">
-            <a:avLst/>
-          </a:prstGeom>
-          <a:noFill/>
-        </p:spPr>
-        <p:txBody>
-          <a:bodyPr wrap="none" lIns="45720" rIns="45720" anchor="t">
-            <a:spAutoFit/>
-          </a:bodyPr>
-          <a:lstStyle/>
-          <a:p>
-            <a:pPr algn="l"/>
-            <a:r>
-              <a:rPr sz="890" b="0">
-                <a:solidFill>
-                  <a:srgbClr val="1F2933"/>
-                </a:solidFill>
-                <a:latin typeface="Aptos"/>
-              </a:rPr>
-              <a:t>Handles missingness and ranks feature importance without forcing a single curve relationship.</a:t>
-            </a:r>
-          </a:p>
-        </p:txBody>
-      </p:sp>
-      <p:sp>
-        <p:nvSpPr>
-          <p:cNvPr id="17" name="Rounded Rectangle 16"/>
-          <p:cNvSpPr/>
-          <p:nvPr/>
-        </p:nvSpPr>
-        <p:spPr>
-          <a:xfrm>
-            <a:off x="685800" y="3749039"/>
-            <a:ext cx="2514600" cy="914400"/>
-          </a:xfrm>
-          <a:prstGeom prst="roundRect">
-            <a:avLst/>
-          </a:prstGeom>
-          <a:solidFill>
-            <a:srgbClr val="EAF5F6"/>
-          </a:solidFill>
-          <a:ln w="13970">
-            <a:solidFill>
-              <a:srgbClr val="167D8D"/>
-            </a:solidFill>
-          </a:ln>
-        </p:spPr>
-        <p:style>
-          <a:lnRef idx="1">
-            <a:schemeClr val="accent1"/>
-          </a:lnRef>
-          <a:fillRef idx="3">
-            <a:schemeClr val="accent1"/>
-          </a:fillRef>
-          <a:effectRef idx="2">
-            <a:schemeClr val="accent1"/>
-          </a:effectRef>
-          <a:fontRef idx="minor">
-            <a:schemeClr val="lt1"/>
-          </a:fontRef>
-        </p:style>
-        <p:txBody>
-          <a:bodyPr rtlCol="0" anchor="ctr"/>
-          <a:lstStyle/>
-          <a:p>
-            <a:pPr algn="ctr"/>
-          </a:p>
-        </p:txBody>
-      </p:sp>
-      <p:sp>
-        <p:nvSpPr>
-          <p:cNvPr id="18" name="TextBox 17"/>
-          <p:cNvSpPr txBox="1"/>
-          <p:nvPr/>
-        </p:nvSpPr>
-        <p:spPr>
-          <a:xfrm>
-            <a:off x="795528" y="3840479"/>
-            <a:ext cx="2295144" cy="246888"/>
-          </a:xfrm>
-          <a:prstGeom prst="rect">
-            <a:avLst/>
-          </a:prstGeom>
-          <a:noFill/>
-        </p:spPr>
-        <p:txBody>
-          <a:bodyPr wrap="none" lIns="45720" rIns="45720" anchor="t">
-            <a:spAutoFit/>
-          </a:bodyPr>
-          <a:lstStyle/>
-          <a:p>
-            <a:pPr algn="l"/>
-            <a:r>
-              <a:rPr sz="1220" b="1">
-                <a:solidFill>
-                  <a:srgbClr val="123447"/>
-                </a:solidFill>
-                <a:latin typeface="Aptos"/>
-              </a:rPr>
-              <a:t>ANN/Keras test</a:t>
-            </a:r>
-          </a:p>
-        </p:txBody>
-      </p:sp>
-      <p:sp>
-        <p:nvSpPr>
-          <p:cNvPr id="19" name="TextBox 18"/>
-          <p:cNvSpPr txBox="1"/>
-          <p:nvPr/>
-        </p:nvSpPr>
-        <p:spPr>
-          <a:xfrm>
-            <a:off x="795528" y="4133087"/>
-            <a:ext cx="2295144" cy="475488"/>
-          </a:xfrm>
-          <a:prstGeom prst="rect">
-            <a:avLst/>
-          </a:prstGeom>
-          <a:noFill/>
-        </p:spPr>
-        <p:txBody>
-          <a:bodyPr wrap="none" lIns="45720" rIns="45720" anchor="t">
-            <a:spAutoFit/>
-          </a:bodyPr>
-          <a:lstStyle/>
-          <a:p>
-            <a:pPr algn="l"/>
-            <a:r>
-              <a:rPr sz="890" b="0">
-                <a:solidFill>
-                  <a:srgbClr val="1F2933"/>
-                </a:solidFill>
-                <a:latin typeface="Aptos"/>
-              </a:rPr>
-              <a:t>Best fit for nonlinear interactions among Rt, porosity, density, Vp, Vs, GR, and NMR-supported targets.</a:t>
-            </a:r>
-          </a:p>
-        </p:txBody>
-      </p:sp>
-      <p:sp>
-        <p:nvSpPr>
-          <p:cNvPr id="20" name="Rounded Rectangle 19"/>
-          <p:cNvSpPr/>
-          <p:nvPr/>
-        </p:nvSpPr>
-        <p:spPr>
-          <a:xfrm>
-            <a:off x="3429000" y="3749039"/>
-            <a:ext cx="2514600" cy="914400"/>
-          </a:xfrm>
-          <a:prstGeom prst="roundRect">
-            <a:avLst/>
-          </a:prstGeom>
-          <a:solidFill>
-            <a:srgbClr val="F4EFE6"/>
-          </a:solidFill>
-          <a:ln w="13970">
-            <a:solidFill>
-              <a:srgbClr val="167D8D"/>
-            </a:solidFill>
-          </a:ln>
-        </p:spPr>
-        <p:style>
-          <a:lnRef idx="1">
-            <a:schemeClr val="accent1"/>
-          </a:lnRef>
-          <a:fillRef idx="3">
-            <a:schemeClr val="accent1"/>
-          </a:fillRef>
-          <a:effectRef idx="2">
-            <a:schemeClr val="accent1"/>
-          </a:effectRef>
-          <a:fontRef idx="minor">
-            <a:schemeClr val="lt1"/>
-          </a:fontRef>
-        </p:style>
-        <p:txBody>
-          <a:bodyPr rtlCol="0" anchor="ctr"/>
-          <a:lstStyle/>
-          <a:p>
-            <a:pPr algn="ctr"/>
-          </a:p>
-        </p:txBody>
-      </p:sp>
-      <p:sp>
-        <p:nvSpPr>
-          <p:cNvPr id="21" name="TextBox 20"/>
-          <p:cNvSpPr txBox="1"/>
-          <p:nvPr/>
-        </p:nvSpPr>
-        <p:spPr>
-          <a:xfrm>
-            <a:off x="3538728" y="3840479"/>
-            <a:ext cx="2295144" cy="246888"/>
-          </a:xfrm>
-          <a:prstGeom prst="rect">
-            <a:avLst/>
-          </a:prstGeom>
-          <a:noFill/>
-        </p:spPr>
-        <p:txBody>
-          <a:bodyPr wrap="none" lIns="45720" rIns="45720" anchor="t">
-            <a:spAutoFit/>
-          </a:bodyPr>
-          <a:lstStyle/>
-          <a:p>
-            <a:pPr algn="l"/>
-            <a:r>
-              <a:rPr sz="1220" b="1">
-                <a:solidFill>
-                  <a:srgbClr val="123447"/>
-                </a:solidFill>
-                <a:latin typeface="Aptos"/>
-              </a:rPr>
-              <a:t>Guardrail</a:t>
-            </a:r>
-          </a:p>
-        </p:txBody>
-      </p:sp>
-      <p:sp>
-        <p:nvSpPr>
-          <p:cNvPr id="22" name="TextBox 21"/>
-          <p:cNvSpPr txBox="1"/>
-          <p:nvPr/>
-        </p:nvSpPr>
-        <p:spPr>
-          <a:xfrm>
-            <a:off x="3538728" y="4133087"/>
-            <a:ext cx="2295144" cy="475488"/>
-          </a:xfrm>
-          <a:prstGeom prst="rect">
-            <a:avLst/>
-          </a:prstGeom>
-          <a:noFill/>
-        </p:spPr>
-        <p:txBody>
-          <a:bodyPr wrap="none" lIns="45720" rIns="45720" anchor="t">
-            <a:spAutoFit/>
-          </a:bodyPr>
-          <a:lstStyle/>
-          <a:p>
-            <a:pPr algn="l"/>
-            <a:r>
-              <a:rPr sz="890" b="0">
-                <a:solidFill>
-                  <a:srgbClr val="1F2933"/>
-                </a:solidFill>
-                <a:latin typeface="Aptos"/>
-              </a:rPr>
-              <a:t>Do not train on Sgh, phase labels, rankings, or NMR-derived target columns as inputs.</a:t>
-            </a:r>
-          </a:p>
-        </p:txBody>
-      </p:sp>
-      <p:sp>
-        <p:nvSpPr>
-          <p:cNvPr id="23" name="Rounded Rectangle 22"/>
-          <p:cNvSpPr/>
-          <p:nvPr/>
-        </p:nvSpPr>
-        <p:spPr>
-          <a:xfrm>
-            <a:off x="6446520" y="3977639"/>
-            <a:ext cx="4846320" cy="914400"/>
-          </a:xfrm>
-          <a:prstGeom prst="roundRect">
-            <a:avLst/>
-          </a:prstGeom>
-          <a:solidFill>
-            <a:srgbClr val="EAF5F6"/>
-          </a:solidFill>
-          <a:ln w="13970">
-            <a:solidFill>
-              <a:srgbClr val="167D8D"/>
-            </a:solidFill>
-          </a:ln>
-        </p:spPr>
-        <p:style>
-          <a:lnRef idx="1">
-            <a:schemeClr val="accent1"/>
-          </a:lnRef>
-          <a:fillRef idx="3">
-            <a:schemeClr val="accent1"/>
-          </a:fillRef>
-          <a:effectRef idx="2">
-            <a:schemeClr val="accent1"/>
-          </a:effectRef>
-          <a:fontRef idx="minor">
-            <a:schemeClr val="lt1"/>
-          </a:fontRef>
-        </p:style>
-        <p:txBody>
-          <a:bodyPr rtlCol="0" anchor="ctr"/>
-          <a:lstStyle/>
-          <a:p>
-            <a:pPr algn="ctr"/>
-          </a:p>
-        </p:txBody>
-      </p:sp>
-      <p:sp>
-        <p:nvSpPr>
-          <p:cNvPr id="24" name="TextBox 23"/>
-          <p:cNvSpPr txBox="1"/>
-          <p:nvPr/>
-        </p:nvSpPr>
-        <p:spPr>
-          <a:xfrm>
-            <a:off x="6556248" y="4069079"/>
-            <a:ext cx="4626864" cy="246888"/>
-          </a:xfrm>
-          <a:prstGeom prst="rect">
-            <a:avLst/>
-          </a:prstGeom>
-          <a:noFill/>
-        </p:spPr>
-        <p:txBody>
-          <a:bodyPr wrap="none" lIns="45720" rIns="45720" anchor="t">
-            <a:spAutoFit/>
-          </a:bodyPr>
-          <a:lstStyle/>
-          <a:p>
-            <a:pPr algn="l"/>
-            <a:r>
-              <a:rPr sz="1220" b="1">
-                <a:solidFill>
-                  <a:srgbClr val="123447"/>
-                </a:solidFill>
-                <a:latin typeface="Aptos"/>
-              </a:rPr>
-              <a:t>Decision logic</a:t>
-            </a:r>
-          </a:p>
-        </p:txBody>
-      </p:sp>
-      <p:sp>
-        <p:nvSpPr>
-          <p:cNvPr id="25" name="TextBox 24"/>
-          <p:cNvSpPr txBox="1"/>
-          <p:nvPr/>
-        </p:nvSpPr>
-        <p:spPr>
-          <a:xfrm>
-            <a:off x="6556248" y="4361688"/>
-            <a:ext cx="4626864" cy="475488"/>
-          </a:xfrm>
-          <a:prstGeom prst="rect">
-            <a:avLst/>
-          </a:prstGeom>
-          <a:noFill/>
-        </p:spPr>
-        <p:txBody>
-          <a:bodyPr wrap="none" lIns="45720" rIns="45720" anchor="t">
-            <a:spAutoFit/>
-          </a:bodyPr>
-          <a:lstStyle/>
-          <a:p>
-            <a:pPr algn="l"/>
-            <a:r>
-              <a:rPr sz="890" b="0">
-                <a:solidFill>
-                  <a:srgbClr val="1F2933"/>
-                </a:solidFill>
-                <a:latin typeface="Aptos"/>
-              </a:rPr>
-              <a:t>Use the ANN only if it improves held-out-well performance beyond explainable baselines and stays geologically reasonable.</a:t>
-            </a:r>
-          </a:p>
-        </p:txBody>
-      </p:sp>
-      <p:sp>
-        <p:nvSpPr>
-          <p:cNvPr id="26" name="TextBox 25"/>
+              <a:t>Built now versus approved-data activation, blockers, deliverables.</a:t>
+            </a:r>
+          </a:p>
+        </p:txBody>
+      </p:sp>
+      <p:sp>
+        <p:nvSpPr>
+          <p:cNvPr id="14" name="TextBox 13"/>
           <p:cNvSpPr txBox="1"/>
           <p:nvPr/>
         </p:nvSpPr>
@@ -8517,7 +7426,7 @@
                 </a:solidFill>
                 <a:latin typeface="Aptos"/>
               </a:rPr>
-              <a:t>Sources: Chong et al. 2022; USGS/NETL hydrate well-log studies; project target-leakage rules.</a:t>
+              <a:t>Public website remains synthetic/public-source only; legacy eight-page links route into the four current pages.</a:t>
             </a:r>
           </a:p>
         </p:txBody>

</xml_diff>